<commit_message>
feat: bundle the blue master and a light slide template
hv_ppt_template.pptx is refreshed from the SharePoint master
(Analysis Team Templates/sl.template_hvti_blue.current.pptx) with its
example slides removed. hv_ppt_template_light.pptx is the bundled light
deck without its eight example slides, for theme_hv_ppt_light().

Co-Authored-By: Claude Opus 5.5 <noreply@anthropic.com>
</commit_message>
<xml_diff>
--- a/inst/extdata/hv_ppt_template.pptx
+++ b/inst/extdata/hv_ppt_template.pptx
@@ -4,6 +4,12 @@
   <p:sldMasterIdLst>
     <p:sldMasterId id="2147483921" r:id="rId4"/>
   </p:sldMasterIdLst>
+  <p:notesMasterIdLst>
+    <p:notesMasterId r:id="rId20"/>
+  </p:notesMasterIdLst>
+  <p:handoutMasterIdLst>
+    <p:handoutMasterId r:id="rId21"/>
+  </p:handoutMasterIdLst>
   <p:sldIdLst/>
   <p:sldSz cx="12192000" cy="6858000"/>
   <p:notesSz cx="6858000" cy="9144000"/>
@@ -160,6 +166,11 @@
             <a:srgbClr val="A4A3A4"/>
           </p15:clr>
         </p15:guide>
+        <p15:guide id="6" orient="horz" pos="1344" userDrawn="1">
+          <p15:clr>
+            <a:srgbClr val="A4A3A4"/>
+          </p15:clr>
+        </p15:guide>
         <p15:guide id="7" orient="horz" pos="1440" userDrawn="1">
           <p15:clr>
             <a:srgbClr val="A4A3A4"/>
@@ -172,11 +183,1187 @@
         </p15:guide>
       </p15:sldGuideLst>
     </p:ext>
-    <p:ext uri="{2D200454-40CA-4A62-9FC3-DE9A4176ACB9}">
-      <p15:notesGuideLst xmlns:p15="http://schemas.microsoft.com/office/powerpoint/2012/main"/>
-    </p:ext>
   </p:extLst>
 </p:presentation>
+</file>
+
+<file path=ppt/revisionInfo.xml><?xml version="1.0" encoding="utf-8"?>
+<p1510:revInfo xmlns:a="http://schemas.openxmlformats.org/drawingml/2006/main" xmlns:r="http://schemas.openxmlformats.org/officeDocument/2006/relationships" xmlns:p1510="http://schemas.microsoft.com/office/powerpoint/2015/10/main">
+  <p1510:revLst>
+    <p1510:client id="{5CA627F3-DA7C-4386-A107-C3DAA35D7F46}" v="8" dt="2026-04-10T15:10:34.455"/>
+  </p1510:revLst>
+</p1510:revInfo>
+</file>
+
+<file path=ppt/handoutMasters/handoutMaster1.xml><?xml version="1.0" encoding="utf-8"?>
+<p:handoutMaster xmlns:a="http://schemas.openxmlformats.org/drawingml/2006/main" xmlns:r="http://schemas.openxmlformats.org/officeDocument/2006/relationships" xmlns:p="http://schemas.openxmlformats.org/presentationml/2006/main">
+  <p:cSld>
+    <p:bg>
+      <p:bgPr>
+        <a:solidFill>
+          <a:schemeClr val="bg1"/>
+        </a:solidFill>
+        <a:effectLst/>
+      </p:bgPr>
+    </p:bg>
+    <p:spTree>
+      <p:nvGrpSpPr>
+        <p:cNvPr id="1" name=""/>
+        <p:cNvGrpSpPr/>
+        <p:nvPr/>
+      </p:nvGrpSpPr>
+      <p:grpSpPr>
+        <a:xfrm>
+          <a:off x="0" y="0"/>
+          <a:ext cx="0" cy="0"/>
+          <a:chOff x="0" y="0"/>
+          <a:chExt cx="0" cy="0"/>
+        </a:xfrm>
+      </p:grpSpPr>
+      <p:sp>
+        <p:nvSpPr>
+          <p:cNvPr id="1321986" name="Rectangle 2"/>
+          <p:cNvSpPr>
+            <a:spLocks noGrp="1" noChangeArrowheads="1"/>
+          </p:cNvSpPr>
+          <p:nvPr>
+            <p:ph type="hdr" sz="quarter"/>
+          </p:nvPr>
+        </p:nvSpPr>
+        <p:spPr bwMode="auto">
+          <a:xfrm>
+            <a:off x="0" y="0"/>
+            <a:ext cx="2971800" cy="457200"/>
+          </a:xfrm>
+          <a:prstGeom prst="rect">
+            <a:avLst/>
+          </a:prstGeom>
+          <a:noFill/>
+          <a:ln w="9525">
+            <a:noFill/>
+            <a:miter lim="800000"/>
+            <a:headEnd/>
+            <a:tailEnd/>
+          </a:ln>
+          <a:effectLst/>
+        </p:spPr>
+        <p:txBody>
+          <a:bodyPr vert="horz" wrap="square" lIns="91440" tIns="45720" rIns="91440" bIns="45720" numCol="1" anchor="t" anchorCtr="0" compatLnSpc="1">
+            <a:prstTxWarp prst="textNoShape">
+              <a:avLst/>
+            </a:prstTxWarp>
+          </a:bodyPr>
+          <a:lstStyle>
+            <a:lvl1pPr>
+              <a:defRPr sz="1200">
+                <a:latin typeface="Times New Roman" pitchFamily="18" charset="0"/>
+              </a:defRPr>
+            </a:lvl1pPr>
+          </a:lstStyle>
+          <a:p>
+            <a:pPr>
+              <a:defRPr/>
+            </a:pPr>
+            <a:endParaRPr lang="en-US"/>
+          </a:p>
+        </p:txBody>
+      </p:sp>
+      <p:sp>
+        <p:nvSpPr>
+          <p:cNvPr id="1321987" name="Rectangle 3"/>
+          <p:cNvSpPr>
+            <a:spLocks noGrp="1" noChangeArrowheads="1"/>
+          </p:cNvSpPr>
+          <p:nvPr>
+            <p:ph type="dt" sz="quarter" idx="1"/>
+          </p:nvPr>
+        </p:nvSpPr>
+        <p:spPr bwMode="auto">
+          <a:xfrm>
+            <a:off x="3884613" y="0"/>
+            <a:ext cx="2971800" cy="457200"/>
+          </a:xfrm>
+          <a:prstGeom prst="rect">
+            <a:avLst/>
+          </a:prstGeom>
+          <a:noFill/>
+          <a:ln w="9525">
+            <a:noFill/>
+            <a:miter lim="800000"/>
+            <a:headEnd/>
+            <a:tailEnd/>
+          </a:ln>
+          <a:effectLst/>
+        </p:spPr>
+        <p:txBody>
+          <a:bodyPr vert="horz" wrap="square" lIns="91440" tIns="45720" rIns="91440" bIns="45720" numCol="1" anchor="t" anchorCtr="0" compatLnSpc="1">
+            <a:prstTxWarp prst="textNoShape">
+              <a:avLst/>
+            </a:prstTxWarp>
+          </a:bodyPr>
+          <a:lstStyle>
+            <a:lvl1pPr algn="r">
+              <a:defRPr sz="1200">
+                <a:latin typeface="Times New Roman" pitchFamily="18" charset="0"/>
+              </a:defRPr>
+            </a:lvl1pPr>
+          </a:lstStyle>
+          <a:p>
+            <a:pPr>
+              <a:defRPr/>
+            </a:pPr>
+            <a:endParaRPr lang="en-US"/>
+          </a:p>
+        </p:txBody>
+      </p:sp>
+      <p:sp>
+        <p:nvSpPr>
+          <p:cNvPr id="1321988" name="Rectangle 4"/>
+          <p:cNvSpPr>
+            <a:spLocks noGrp="1" noChangeArrowheads="1"/>
+          </p:cNvSpPr>
+          <p:nvPr>
+            <p:ph type="ftr" sz="quarter" idx="2"/>
+          </p:nvPr>
+        </p:nvSpPr>
+        <p:spPr bwMode="auto">
+          <a:xfrm>
+            <a:off x="0" y="8685213"/>
+            <a:ext cx="2971800" cy="457200"/>
+          </a:xfrm>
+          <a:prstGeom prst="rect">
+            <a:avLst/>
+          </a:prstGeom>
+          <a:noFill/>
+          <a:ln w="9525">
+            <a:noFill/>
+            <a:miter lim="800000"/>
+            <a:headEnd/>
+            <a:tailEnd/>
+          </a:ln>
+          <a:effectLst/>
+        </p:spPr>
+        <p:txBody>
+          <a:bodyPr vert="horz" wrap="square" lIns="91440" tIns="45720" rIns="91440" bIns="45720" numCol="1" anchor="b" anchorCtr="0" compatLnSpc="1">
+            <a:prstTxWarp prst="textNoShape">
+              <a:avLst/>
+            </a:prstTxWarp>
+          </a:bodyPr>
+          <a:lstStyle>
+            <a:lvl1pPr>
+              <a:defRPr sz="1200">
+                <a:latin typeface="Times New Roman" pitchFamily="18" charset="0"/>
+              </a:defRPr>
+            </a:lvl1pPr>
+          </a:lstStyle>
+          <a:p>
+            <a:pPr>
+              <a:defRPr/>
+            </a:pPr>
+            <a:endParaRPr lang="en-US"/>
+          </a:p>
+        </p:txBody>
+      </p:sp>
+      <p:sp>
+        <p:nvSpPr>
+          <p:cNvPr id="1321989" name="Rectangle 5"/>
+          <p:cNvSpPr>
+            <a:spLocks noGrp="1" noChangeArrowheads="1"/>
+          </p:cNvSpPr>
+          <p:nvPr>
+            <p:ph type="sldNum" sz="quarter" idx="3"/>
+          </p:nvPr>
+        </p:nvSpPr>
+        <p:spPr bwMode="auto">
+          <a:xfrm>
+            <a:off x="3884613" y="8685213"/>
+            <a:ext cx="2971800" cy="457200"/>
+          </a:xfrm>
+          <a:prstGeom prst="rect">
+            <a:avLst/>
+          </a:prstGeom>
+          <a:noFill/>
+          <a:ln w="9525">
+            <a:noFill/>
+            <a:miter lim="800000"/>
+            <a:headEnd/>
+            <a:tailEnd/>
+          </a:ln>
+          <a:effectLst/>
+        </p:spPr>
+        <p:txBody>
+          <a:bodyPr vert="horz" wrap="square" lIns="91440" tIns="45720" rIns="91440" bIns="45720" numCol="1" anchor="b" anchorCtr="0" compatLnSpc="1">
+            <a:prstTxWarp prst="textNoShape">
+              <a:avLst/>
+            </a:prstTxWarp>
+          </a:bodyPr>
+          <a:lstStyle>
+            <a:lvl1pPr algn="r">
+              <a:defRPr sz="1200">
+                <a:latin typeface="Times New Roman" panose="02020603050405020304" pitchFamily="18" charset="0"/>
+              </a:defRPr>
+            </a:lvl1pPr>
+          </a:lstStyle>
+          <a:p>
+            <a:fld id="{37E83F1E-DC89-462E-BA79-89A77034CE77}" type="slidenum">
+              <a:rPr lang="en-US" altLang="en-US"/>
+              <a:pPr/>
+              <a:t>‹#›</a:t>
+            </a:fld>
+            <a:endParaRPr lang="en-US" altLang="en-US"/>
+          </a:p>
+        </p:txBody>
+      </p:sp>
+    </p:spTree>
+    <p:extLst>
+      <p:ext uri="{BB962C8B-B14F-4D97-AF65-F5344CB8AC3E}">
+        <p14:creationId xmlns:p14="http://schemas.microsoft.com/office/powerpoint/2010/main" val="3956440278"/>
+      </p:ext>
+    </p:extLst>
+  </p:cSld>
+  <p:clrMap bg1="lt1" tx1="dk1" bg2="lt2" tx2="dk2" accent1="accent1" accent2="accent2" accent3="accent3" accent4="accent4" accent5="accent5" accent6="accent6" hlink="hlink" folHlink="folHlink"/>
+</p:handoutMaster>
+</file>
+
+<file path=ppt/notesMasters/notesMaster1.xml><?xml version="1.0" encoding="utf-8"?>
+<p:notesMaster xmlns:a="http://schemas.openxmlformats.org/drawingml/2006/main" xmlns:r="http://schemas.openxmlformats.org/officeDocument/2006/relationships" xmlns:p="http://schemas.openxmlformats.org/presentationml/2006/main">
+  <p:cSld>
+    <p:bg>
+      <p:bgPr>
+        <a:solidFill>
+          <a:schemeClr val="bg1"/>
+        </a:solidFill>
+        <a:effectLst/>
+      </p:bgPr>
+    </p:bg>
+    <p:spTree>
+      <p:nvGrpSpPr>
+        <p:cNvPr id="1" name=""/>
+        <p:cNvGrpSpPr/>
+        <p:nvPr/>
+      </p:nvGrpSpPr>
+      <p:grpSpPr>
+        <a:xfrm>
+          <a:off x="0" y="0"/>
+          <a:ext cx="0" cy="0"/>
+          <a:chOff x="0" y="0"/>
+          <a:chExt cx="0" cy="0"/>
+        </a:xfrm>
+      </p:grpSpPr>
+      <p:sp>
+        <p:nvSpPr>
+          <p:cNvPr id="17410" name="Rectangle 2"/>
+          <p:cNvSpPr>
+            <a:spLocks noGrp="1" noChangeArrowheads="1"/>
+          </p:cNvSpPr>
+          <p:nvPr>
+            <p:ph type="hdr" sz="quarter"/>
+          </p:nvPr>
+        </p:nvSpPr>
+        <p:spPr bwMode="auto">
+          <a:xfrm>
+            <a:off x="0" y="0"/>
+            <a:ext cx="2971800" cy="457200"/>
+          </a:xfrm>
+          <a:prstGeom prst="rect">
+            <a:avLst/>
+          </a:prstGeom>
+          <a:noFill/>
+          <a:ln w="9525">
+            <a:noFill/>
+            <a:miter lim="800000"/>
+            <a:headEnd/>
+            <a:tailEnd/>
+          </a:ln>
+          <a:effectLst/>
+        </p:spPr>
+        <p:txBody>
+          <a:bodyPr vert="horz" wrap="square" lIns="91440" tIns="45720" rIns="91440" bIns="45720" numCol="1" anchor="t" anchorCtr="0" compatLnSpc="1">
+            <a:prstTxWarp prst="textNoShape">
+              <a:avLst/>
+            </a:prstTxWarp>
+          </a:bodyPr>
+          <a:lstStyle>
+            <a:lvl1pPr>
+              <a:defRPr sz="1200">
+                <a:latin typeface="Arial" pitchFamily="34" charset="0"/>
+              </a:defRPr>
+            </a:lvl1pPr>
+          </a:lstStyle>
+          <a:p>
+            <a:pPr>
+              <a:defRPr/>
+            </a:pPr>
+            <a:endParaRPr lang="en-US"/>
+          </a:p>
+        </p:txBody>
+      </p:sp>
+      <p:sp>
+        <p:nvSpPr>
+          <p:cNvPr id="17411" name="Rectangle 3"/>
+          <p:cNvSpPr>
+            <a:spLocks noGrp="1" noChangeArrowheads="1"/>
+          </p:cNvSpPr>
+          <p:nvPr>
+            <p:ph type="dt" idx="1"/>
+          </p:nvPr>
+        </p:nvSpPr>
+        <p:spPr bwMode="auto">
+          <a:xfrm>
+            <a:off x="3886200" y="0"/>
+            <a:ext cx="2971800" cy="457200"/>
+          </a:xfrm>
+          <a:prstGeom prst="rect">
+            <a:avLst/>
+          </a:prstGeom>
+          <a:noFill/>
+          <a:ln w="9525">
+            <a:noFill/>
+            <a:miter lim="800000"/>
+            <a:headEnd/>
+            <a:tailEnd/>
+          </a:ln>
+          <a:effectLst/>
+        </p:spPr>
+        <p:txBody>
+          <a:bodyPr vert="horz" wrap="square" lIns="91440" tIns="45720" rIns="91440" bIns="45720" numCol="1" anchor="t" anchorCtr="0" compatLnSpc="1">
+            <a:prstTxWarp prst="textNoShape">
+              <a:avLst/>
+            </a:prstTxWarp>
+          </a:bodyPr>
+          <a:lstStyle>
+            <a:lvl1pPr algn="r">
+              <a:defRPr sz="1200">
+                <a:latin typeface="Arial" pitchFamily="34" charset="0"/>
+              </a:defRPr>
+            </a:lvl1pPr>
+          </a:lstStyle>
+          <a:p>
+            <a:pPr>
+              <a:defRPr/>
+            </a:pPr>
+            <a:endParaRPr lang="en-US"/>
+          </a:p>
+        </p:txBody>
+      </p:sp>
+      <p:sp>
+        <p:nvSpPr>
+          <p:cNvPr id="109572" name="Rectangle 4"/>
+          <p:cNvSpPr>
+            <a:spLocks noGrp="1" noRot="1" noChangeAspect="1" noChangeArrowheads="1" noTextEdit="1"/>
+          </p:cNvSpPr>
+          <p:nvPr>
+            <p:ph type="sldImg" idx="2"/>
+          </p:nvPr>
+        </p:nvSpPr>
+        <p:spPr bwMode="auto">
+          <a:xfrm>
+            <a:off x="381000" y="685800"/>
+            <a:ext cx="6096000" cy="3429000"/>
+          </a:xfrm>
+          <a:prstGeom prst="rect">
+            <a:avLst/>
+          </a:prstGeom>
+          <a:noFill/>
+          <a:ln w="9525">
+            <a:solidFill>
+              <a:srgbClr val="000000"/>
+            </a:solidFill>
+            <a:miter lim="800000"/>
+            <a:headEnd/>
+            <a:tailEnd/>
+          </a:ln>
+          <a:extLst>
+            <a:ext uri="{909E8E84-426E-40DD-AFC4-6F175D3DCCD1}">
+              <a14:hiddenFill xmlns:a14="http://schemas.microsoft.com/office/drawing/2010/main">
+                <a:solidFill>
+                  <a:srgbClr val="FFFFFF"/>
+                </a:solidFill>
+              </a14:hiddenFill>
+            </a:ext>
+          </a:extLst>
+        </p:spPr>
+      </p:sp>
+      <p:sp>
+        <p:nvSpPr>
+          <p:cNvPr id="17413" name="Rectangle 5"/>
+          <p:cNvSpPr>
+            <a:spLocks noGrp="1" noChangeArrowheads="1"/>
+          </p:cNvSpPr>
+          <p:nvPr>
+            <p:ph type="body" sz="quarter" idx="3"/>
+          </p:nvPr>
+        </p:nvSpPr>
+        <p:spPr bwMode="auto">
+          <a:xfrm>
+            <a:off x="914400" y="4343400"/>
+            <a:ext cx="5029200" cy="4114800"/>
+          </a:xfrm>
+          <a:prstGeom prst="rect">
+            <a:avLst/>
+          </a:prstGeom>
+          <a:noFill/>
+          <a:ln w="9525">
+            <a:noFill/>
+            <a:miter lim="800000"/>
+            <a:headEnd/>
+            <a:tailEnd/>
+          </a:ln>
+          <a:effectLst/>
+        </p:spPr>
+        <p:txBody>
+          <a:bodyPr vert="horz" wrap="square" lIns="91440" tIns="45720" rIns="91440" bIns="45720" numCol="1" anchor="t" anchorCtr="0" compatLnSpc="1">
+            <a:prstTxWarp prst="textNoShape">
+              <a:avLst/>
+            </a:prstTxWarp>
+          </a:bodyPr>
+          <a:lstStyle/>
+          <a:p>
+            <a:pPr lvl="0"/>
+            <a:r>
+              <a:rPr lang="en-US" noProof="0"/>
+              <a:t>Click to edit Master text styles</a:t>
+            </a:r>
+          </a:p>
+          <a:p>
+            <a:pPr lvl="1"/>
+            <a:r>
+              <a:rPr lang="en-US" noProof="0"/>
+              <a:t>Second level</a:t>
+            </a:r>
+          </a:p>
+          <a:p>
+            <a:pPr lvl="2"/>
+            <a:r>
+              <a:rPr lang="en-US" noProof="0"/>
+              <a:t>Third level</a:t>
+            </a:r>
+          </a:p>
+          <a:p>
+            <a:pPr lvl="3"/>
+            <a:r>
+              <a:rPr lang="en-US" noProof="0"/>
+              <a:t>Fourth level</a:t>
+            </a:r>
+          </a:p>
+          <a:p>
+            <a:pPr lvl="4"/>
+            <a:r>
+              <a:rPr lang="en-US" noProof="0"/>
+              <a:t>Fifth level</a:t>
+            </a:r>
+          </a:p>
+        </p:txBody>
+      </p:sp>
+      <p:sp>
+        <p:nvSpPr>
+          <p:cNvPr id="17414" name="Rectangle 6"/>
+          <p:cNvSpPr>
+            <a:spLocks noGrp="1" noChangeArrowheads="1"/>
+          </p:cNvSpPr>
+          <p:nvPr>
+            <p:ph type="ftr" sz="quarter" idx="4"/>
+          </p:nvPr>
+        </p:nvSpPr>
+        <p:spPr bwMode="auto">
+          <a:xfrm>
+            <a:off x="0" y="8686800"/>
+            <a:ext cx="2971800" cy="457200"/>
+          </a:xfrm>
+          <a:prstGeom prst="rect">
+            <a:avLst/>
+          </a:prstGeom>
+          <a:noFill/>
+          <a:ln w="9525">
+            <a:noFill/>
+            <a:miter lim="800000"/>
+            <a:headEnd/>
+            <a:tailEnd/>
+          </a:ln>
+          <a:effectLst/>
+        </p:spPr>
+        <p:txBody>
+          <a:bodyPr vert="horz" wrap="square" lIns="91440" tIns="45720" rIns="91440" bIns="45720" numCol="1" anchor="b" anchorCtr="0" compatLnSpc="1">
+            <a:prstTxWarp prst="textNoShape">
+              <a:avLst/>
+            </a:prstTxWarp>
+          </a:bodyPr>
+          <a:lstStyle>
+            <a:lvl1pPr>
+              <a:defRPr sz="1200">
+                <a:latin typeface="Arial" pitchFamily="34" charset="0"/>
+              </a:defRPr>
+            </a:lvl1pPr>
+          </a:lstStyle>
+          <a:p>
+            <a:pPr>
+              <a:defRPr/>
+            </a:pPr>
+            <a:endParaRPr lang="en-US"/>
+          </a:p>
+        </p:txBody>
+      </p:sp>
+      <p:sp>
+        <p:nvSpPr>
+          <p:cNvPr id="17415" name="Rectangle 7"/>
+          <p:cNvSpPr>
+            <a:spLocks noGrp="1" noChangeArrowheads="1"/>
+          </p:cNvSpPr>
+          <p:nvPr>
+            <p:ph type="sldNum" sz="quarter" idx="5"/>
+          </p:nvPr>
+        </p:nvSpPr>
+        <p:spPr bwMode="auto">
+          <a:xfrm>
+            <a:off x="3886200" y="8686800"/>
+            <a:ext cx="2971800" cy="457200"/>
+          </a:xfrm>
+          <a:prstGeom prst="rect">
+            <a:avLst/>
+          </a:prstGeom>
+          <a:noFill/>
+          <a:ln w="9525">
+            <a:noFill/>
+            <a:miter lim="800000"/>
+            <a:headEnd/>
+            <a:tailEnd/>
+          </a:ln>
+          <a:effectLst/>
+        </p:spPr>
+        <p:txBody>
+          <a:bodyPr vert="horz" wrap="square" lIns="91440" tIns="45720" rIns="91440" bIns="45720" numCol="1" anchor="b" anchorCtr="0" compatLnSpc="1">
+            <a:prstTxWarp prst="textNoShape">
+              <a:avLst/>
+            </a:prstTxWarp>
+          </a:bodyPr>
+          <a:lstStyle>
+            <a:lvl1pPr algn="r">
+              <a:defRPr sz="1200"/>
+            </a:lvl1pPr>
+          </a:lstStyle>
+          <a:p>
+            <a:fld id="{98DB9D90-18B0-4CF8-86DE-169EA001EB17}" type="slidenum">
+              <a:rPr lang="en-US" altLang="en-US"/>
+              <a:pPr/>
+              <a:t>‹#›</a:t>
+            </a:fld>
+            <a:endParaRPr lang="en-US" altLang="en-US"/>
+          </a:p>
+        </p:txBody>
+      </p:sp>
+    </p:spTree>
+    <p:extLst>
+      <p:ext uri="{BB962C8B-B14F-4D97-AF65-F5344CB8AC3E}">
+        <p14:creationId xmlns:p14="http://schemas.microsoft.com/office/powerpoint/2010/main" val="605188731"/>
+      </p:ext>
+    </p:extLst>
+  </p:cSld>
+  <p:clrMap bg1="lt1" tx1="dk1" bg2="lt2" tx2="dk2" accent1="accent1" accent2="accent2" accent3="accent3" accent4="accent4" accent5="accent5" accent6="accent6" hlink="hlink" folHlink="folHlink"/>
+  <p:notesStyle>
+    <a:lvl1pPr algn="l" rtl="0" eaLnBrk="0" fontAlgn="base" hangingPunct="0">
+      <a:spcBef>
+        <a:spcPct val="30000"/>
+      </a:spcBef>
+      <a:spcAft>
+        <a:spcPct val="0"/>
+      </a:spcAft>
+      <a:defRPr sz="1200" kern="1200">
+        <a:solidFill>
+          <a:schemeClr val="tx1"/>
+        </a:solidFill>
+        <a:latin typeface="Times New Roman" pitchFamily="18" charset="0"/>
+        <a:ea typeface="+mn-ea"/>
+        <a:cs typeface="+mn-cs"/>
+      </a:defRPr>
+    </a:lvl1pPr>
+    <a:lvl2pPr marL="457200" algn="l" rtl="0" eaLnBrk="0" fontAlgn="base" hangingPunct="0">
+      <a:spcBef>
+        <a:spcPct val="30000"/>
+      </a:spcBef>
+      <a:spcAft>
+        <a:spcPct val="0"/>
+      </a:spcAft>
+      <a:defRPr sz="1200" kern="1200">
+        <a:solidFill>
+          <a:schemeClr val="tx1"/>
+        </a:solidFill>
+        <a:latin typeface="Times New Roman" pitchFamily="18" charset="0"/>
+        <a:ea typeface="+mn-ea"/>
+        <a:cs typeface="+mn-cs"/>
+      </a:defRPr>
+    </a:lvl2pPr>
+    <a:lvl3pPr marL="914400" algn="l" rtl="0" eaLnBrk="0" fontAlgn="base" hangingPunct="0">
+      <a:spcBef>
+        <a:spcPct val="30000"/>
+      </a:spcBef>
+      <a:spcAft>
+        <a:spcPct val="0"/>
+      </a:spcAft>
+      <a:defRPr sz="1200" kern="1200">
+        <a:solidFill>
+          <a:schemeClr val="tx1"/>
+        </a:solidFill>
+        <a:latin typeface="Times New Roman" pitchFamily="18" charset="0"/>
+        <a:ea typeface="+mn-ea"/>
+        <a:cs typeface="+mn-cs"/>
+      </a:defRPr>
+    </a:lvl3pPr>
+    <a:lvl4pPr marL="1371600" algn="l" rtl="0" eaLnBrk="0" fontAlgn="base" hangingPunct="0">
+      <a:spcBef>
+        <a:spcPct val="30000"/>
+      </a:spcBef>
+      <a:spcAft>
+        <a:spcPct val="0"/>
+      </a:spcAft>
+      <a:defRPr sz="1200" kern="1200">
+        <a:solidFill>
+          <a:schemeClr val="tx1"/>
+        </a:solidFill>
+        <a:latin typeface="Times New Roman" pitchFamily="18" charset="0"/>
+        <a:ea typeface="+mn-ea"/>
+        <a:cs typeface="+mn-cs"/>
+      </a:defRPr>
+    </a:lvl4pPr>
+    <a:lvl5pPr marL="1828800" algn="l" rtl="0" eaLnBrk="0" fontAlgn="base" hangingPunct="0">
+      <a:spcBef>
+        <a:spcPct val="30000"/>
+      </a:spcBef>
+      <a:spcAft>
+        <a:spcPct val="0"/>
+      </a:spcAft>
+      <a:defRPr sz="1200" kern="1200">
+        <a:solidFill>
+          <a:schemeClr val="tx1"/>
+        </a:solidFill>
+        <a:latin typeface="Times New Roman" pitchFamily="18" charset="0"/>
+        <a:ea typeface="+mn-ea"/>
+        <a:cs typeface="+mn-cs"/>
+      </a:defRPr>
+    </a:lvl5pPr>
+    <a:lvl6pPr marL="2286000" algn="l" defTabSz="914400" rtl="0" eaLnBrk="1" latinLnBrk="0" hangingPunct="1">
+      <a:defRPr sz="1200" kern="1200">
+        <a:solidFill>
+          <a:schemeClr val="tx1"/>
+        </a:solidFill>
+        <a:latin typeface="+mn-lt"/>
+        <a:ea typeface="+mn-ea"/>
+        <a:cs typeface="+mn-cs"/>
+      </a:defRPr>
+    </a:lvl6pPr>
+    <a:lvl7pPr marL="2743200" algn="l" defTabSz="914400" rtl="0" eaLnBrk="1" latinLnBrk="0" hangingPunct="1">
+      <a:defRPr sz="1200" kern="1200">
+        <a:solidFill>
+          <a:schemeClr val="tx1"/>
+        </a:solidFill>
+        <a:latin typeface="+mn-lt"/>
+        <a:ea typeface="+mn-ea"/>
+        <a:cs typeface="+mn-cs"/>
+      </a:defRPr>
+    </a:lvl7pPr>
+    <a:lvl8pPr marL="3200400" algn="l" defTabSz="914400" rtl="0" eaLnBrk="1" latinLnBrk="0" hangingPunct="1">
+      <a:defRPr sz="1200" kern="1200">
+        <a:solidFill>
+          <a:schemeClr val="tx1"/>
+        </a:solidFill>
+        <a:latin typeface="+mn-lt"/>
+        <a:ea typeface="+mn-ea"/>
+        <a:cs typeface="+mn-cs"/>
+      </a:defRPr>
+    </a:lvl8pPr>
+    <a:lvl9pPr marL="3657600" algn="l" defTabSz="914400" rtl="0" eaLnBrk="1" latinLnBrk="0" hangingPunct="1">
+      <a:defRPr sz="1200" kern="1200">
+        <a:solidFill>
+          <a:schemeClr val="tx1"/>
+        </a:solidFill>
+        <a:latin typeface="+mn-lt"/>
+        <a:ea typeface="+mn-ea"/>
+        <a:cs typeface="+mn-cs"/>
+      </a:defRPr>
+    </a:lvl9pPr>
+  </p:notesStyle>
+</p:notesMaster>
+</file>
+
+<file path=ppt/notesSlides/notesSlide1.xml><?xml version="1.0" encoding="utf-8"?>
+<p:notes xmlns:a="http://schemas.openxmlformats.org/drawingml/2006/main" xmlns:r="http://schemas.openxmlformats.org/officeDocument/2006/relationships" xmlns:p="http://schemas.openxmlformats.org/presentationml/2006/main">
+  <p:cSld>
+    <p:spTree>
+      <p:nvGrpSpPr>
+        <p:cNvPr id="1" name=""/>
+        <p:cNvGrpSpPr/>
+        <p:nvPr/>
+      </p:nvGrpSpPr>
+      <p:grpSpPr>
+        <a:xfrm>
+          <a:off x="0" y="0"/>
+          <a:ext cx="0" cy="0"/>
+          <a:chOff x="0" y="0"/>
+          <a:chExt cx="0" cy="0"/>
+        </a:xfrm>
+      </p:grpSpPr>
+      <p:sp>
+        <p:nvSpPr>
+          <p:cNvPr id="2" name="Slide Image Placeholder 1"/>
+          <p:cNvSpPr>
+            <a:spLocks noGrp="1" noRot="1" noChangeAspect="1"/>
+          </p:cNvSpPr>
+          <p:nvPr>
+            <p:ph type="sldImg"/>
+          </p:nvPr>
+        </p:nvSpPr>
+        <p:spPr/>
+      </p:sp>
+      <p:sp>
+        <p:nvSpPr>
+          <p:cNvPr id="3" name="Notes Placeholder 2"/>
+          <p:cNvSpPr>
+            <a:spLocks noGrp="1"/>
+          </p:cNvSpPr>
+          <p:nvPr>
+            <p:ph type="body" idx="1"/>
+          </p:nvPr>
+        </p:nvSpPr>
+        <p:spPr/>
+        <p:txBody>
+          <a:bodyPr/>
+          <a:lstStyle/>
+          <a:p>
+            <a:r>
+              <a:rPr lang="en-US" b="1" dirty="0"/>
+              <a:t>Try not to use Tables</a:t>
+            </a:r>
+          </a:p>
+        </p:txBody>
+      </p:sp>
+      <p:sp>
+        <p:nvSpPr>
+          <p:cNvPr id="4" name="Slide Number Placeholder 3"/>
+          <p:cNvSpPr>
+            <a:spLocks noGrp="1"/>
+          </p:cNvSpPr>
+          <p:nvPr>
+            <p:ph type="sldNum" sz="quarter" idx="5"/>
+          </p:nvPr>
+        </p:nvSpPr>
+        <p:spPr/>
+        <p:txBody>
+          <a:bodyPr/>
+          <a:lstStyle/>
+          <a:p>
+            <a:pPr>
+              <a:defRPr/>
+            </a:pPr>
+            <a:fld id="{77261A55-EFA6-4C86-86C1-9750DF19D9F0}" type="slidenum">
+              <a:rPr lang="en-US" altLang="en-US" smtClean="0"/>
+              <a:pPr>
+                <a:defRPr/>
+              </a:pPr>
+              <a:t>10</a:t>
+            </a:fld>
+            <a:endParaRPr lang="en-US" altLang="en-US"/>
+          </a:p>
+        </p:txBody>
+      </p:sp>
+    </p:spTree>
+    <p:extLst>
+      <p:ext uri="{BB962C8B-B14F-4D97-AF65-F5344CB8AC3E}">
+        <p14:creationId xmlns:p14="http://schemas.microsoft.com/office/powerpoint/2010/main" val="2423958642"/>
+      </p:ext>
+    </p:extLst>
+  </p:cSld>
+  <p:clrMapOvr>
+    <a:masterClrMapping/>
+  </p:clrMapOvr>
+</p:notes>
+</file>
+
+<file path=ppt/notesSlides/notesSlide2.xml><?xml version="1.0" encoding="utf-8"?>
+<p:notes xmlns:a="http://schemas.openxmlformats.org/drawingml/2006/main" xmlns:r="http://schemas.openxmlformats.org/officeDocument/2006/relationships" xmlns:p="http://schemas.openxmlformats.org/presentationml/2006/main">
+  <p:cSld>
+    <p:spTree>
+      <p:nvGrpSpPr>
+        <p:cNvPr id="1" name=""/>
+        <p:cNvGrpSpPr/>
+        <p:nvPr/>
+      </p:nvGrpSpPr>
+      <p:grpSpPr>
+        <a:xfrm>
+          <a:off x="0" y="0"/>
+          <a:ext cx="0" cy="0"/>
+          <a:chOff x="0" y="0"/>
+          <a:chExt cx="0" cy="0"/>
+        </a:xfrm>
+      </p:grpSpPr>
+      <p:sp>
+        <p:nvSpPr>
+          <p:cNvPr id="7" name="Rectangle 7"/>
+          <p:cNvSpPr>
+            <a:spLocks noGrp="1" noChangeArrowheads="1"/>
+          </p:cNvSpPr>
+          <p:nvPr>
+            <p:ph type="sldNum" sz="quarter" idx="5"/>
+          </p:nvPr>
+        </p:nvSpPr>
+        <p:spPr>
+          <a:ln/>
+        </p:spPr>
+        <p:txBody>
+          <a:bodyPr/>
+          <a:lstStyle/>
+          <a:p>
+            <a:fld id="{623D48AD-1957-4759-B4E1-13C8E0A9AB1A}" type="slidenum">
+              <a:rPr lang="en-US" altLang="en-US"/>
+              <a:pPr/>
+              <a:t>11</a:t>
+            </a:fld>
+            <a:endParaRPr lang="en-US" altLang="en-US"/>
+          </a:p>
+        </p:txBody>
+      </p:sp>
+      <p:sp>
+        <p:nvSpPr>
+          <p:cNvPr id="23554" name="Rectangle 2"/>
+          <p:cNvSpPr>
+            <a:spLocks noGrp="1" noRot="1" noChangeAspect="1" noChangeArrowheads="1" noTextEdit="1"/>
+          </p:cNvSpPr>
+          <p:nvPr>
+            <p:ph type="sldImg"/>
+          </p:nvPr>
+        </p:nvSpPr>
+        <p:spPr>
+          <a:ln/>
+        </p:spPr>
+      </p:sp>
+      <p:sp>
+        <p:nvSpPr>
+          <p:cNvPr id="23555" name="Rectangle 3"/>
+          <p:cNvSpPr>
+            <a:spLocks noGrp="1" noChangeArrowheads="1"/>
+          </p:cNvSpPr>
+          <p:nvPr>
+            <p:ph type="body" idx="1"/>
+          </p:nvPr>
+        </p:nvSpPr>
+        <p:spPr/>
+        <p:txBody>
+          <a:bodyPr/>
+          <a:lstStyle/>
+          <a:p>
+            <a:r>
+              <a:rPr lang="en-US" altLang="en-US" dirty="0"/>
+              <a:t>Pie Chart:</a:t>
+            </a:r>
+          </a:p>
+          <a:p>
+            <a:r>
+              <a:rPr lang="en-US" altLang="en-US" dirty="0"/>
+              <a:t>Double click pie chart to edit data.</a:t>
+            </a:r>
+          </a:p>
+          <a:p>
+            <a:r>
+              <a:rPr lang="en-US" altLang="en-US" dirty="0"/>
+              <a:t>Labels and percentages are added with separate text blocks. Colors are not standardized yet.</a:t>
+            </a:r>
+          </a:p>
+        </p:txBody>
+      </p:sp>
+    </p:spTree>
+    <p:extLst>
+      <p:ext uri="{BB962C8B-B14F-4D97-AF65-F5344CB8AC3E}">
+        <p14:creationId xmlns:p14="http://schemas.microsoft.com/office/powerpoint/2010/main" val="4136693095"/>
+      </p:ext>
+    </p:extLst>
+  </p:cSld>
+  <p:clrMapOvr>
+    <a:masterClrMapping/>
+  </p:clrMapOvr>
+</p:notes>
+</file>
+
+<file path=ppt/notesSlides/notesSlide3.xml><?xml version="1.0" encoding="utf-8"?>
+<p:notes xmlns:a="http://schemas.openxmlformats.org/drawingml/2006/main" xmlns:r="http://schemas.openxmlformats.org/officeDocument/2006/relationships" xmlns:p="http://schemas.openxmlformats.org/presentationml/2006/main">
+  <p:cSld>
+    <p:spTree>
+      <p:nvGrpSpPr>
+        <p:cNvPr id="1" name=""/>
+        <p:cNvGrpSpPr/>
+        <p:nvPr/>
+      </p:nvGrpSpPr>
+      <p:grpSpPr>
+        <a:xfrm>
+          <a:off x="0" y="0"/>
+          <a:ext cx="0" cy="0"/>
+          <a:chOff x="0" y="0"/>
+          <a:chExt cx="0" cy="0"/>
+        </a:xfrm>
+      </p:grpSpPr>
+      <p:sp>
+        <p:nvSpPr>
+          <p:cNvPr id="7" name="Rectangle 7"/>
+          <p:cNvSpPr>
+            <a:spLocks noGrp="1" noChangeArrowheads="1"/>
+          </p:cNvSpPr>
+          <p:nvPr>
+            <p:ph type="sldNum" sz="quarter" idx="5"/>
+          </p:nvPr>
+        </p:nvSpPr>
+        <p:spPr>
+          <a:ln/>
+        </p:spPr>
+        <p:txBody>
+          <a:bodyPr/>
+          <a:lstStyle/>
+          <a:p>
+            <a:fld id="{D557DB31-A8E3-46B3-BAFB-0CF4D9AD5315}" type="slidenum">
+              <a:rPr lang="en-US" altLang="en-US"/>
+              <a:pPr/>
+              <a:t>12</a:t>
+            </a:fld>
+            <a:endParaRPr lang="en-US" altLang="en-US"/>
+          </a:p>
+        </p:txBody>
+      </p:sp>
+      <p:sp>
+        <p:nvSpPr>
+          <p:cNvPr id="28674" name="Rectangle 2"/>
+          <p:cNvSpPr>
+            <a:spLocks noGrp="1" noChangeArrowheads="1"/>
+          </p:cNvSpPr>
+          <p:nvPr>
+            <p:ph type="body" idx="1"/>
+          </p:nvPr>
+        </p:nvSpPr>
+        <p:spPr bwMode="auto">
+          <a:xfrm>
+            <a:off x="912813" y="4343400"/>
+            <a:ext cx="5030787" cy="4114800"/>
+          </a:xfrm>
+          <a:prstGeom prst="rect">
+            <a:avLst/>
+          </a:prstGeom>
+          <a:noFill/>
+          <a:ln/>
+          <a:extLst>
+            <a:ext uri="{909E8E84-426E-40DD-AFC4-6F175D3DCCD1}">
+              <a14:hiddenFill xmlns:a14="http://schemas.microsoft.com/office/drawing/2010/main">
+                <a:solidFill>
+                  <a:srgbClr val="FFFFFF"/>
+                </a:solidFill>
+              </a14:hiddenFill>
+            </a:ext>
+            <a:ext uri="{91240B29-F687-4F45-9708-019B960494DF}">
+              <a14:hiddenLine xmlns:a14="http://schemas.microsoft.com/office/drawing/2010/main" w="12700">
+                <a:solidFill>
+                  <a:srgbClr val="000000"/>
+                </a:solidFill>
+                <a:miter lim="800000"/>
+                <a:headEnd/>
+                <a:tailEnd/>
+              </a14:hiddenLine>
+            </a:ext>
+            <a:ext uri="{AF507438-7753-43E0-B8FC-AC1667EBCBE1}">
+              <a14:hiddenEffects xmlns:a14="http://schemas.microsoft.com/office/drawing/2010/main">
+                <a:effectLst>
+                  <a:outerShdw dist="35921" dir="2700000" algn="ctr" rotWithShape="0">
+                    <a:srgbClr val="808080"/>
+                  </a:outerShdw>
+                </a:effectLst>
+              </a14:hiddenEffects>
+            </a:ext>
+          </a:extLst>
+        </p:spPr>
+        <p:txBody>
+          <a:bodyPr lIns="90488" tIns="44450" rIns="90488" bIns="44450"/>
+          <a:lstStyle/>
+          <a:p>
+            <a:r>
+              <a:rPr lang="en-US" altLang="en-US" sz="2000" dirty="0"/>
+              <a:t>Double click the chart to modify histogram data.  </a:t>
+            </a:r>
+            <a:r>
+              <a:rPr lang="en-US" altLang="en-US" sz="2000" b="1" dirty="0"/>
+              <a:t>Make your own labels(insert text box be sure the size font is 32).</a:t>
+            </a:r>
+          </a:p>
+          <a:p>
+            <a:r>
+              <a:rPr lang="en-US" altLang="en-US" sz="2000" b="1" dirty="0"/>
+              <a:t>Auto-generated axis labels may change the size of your Histogram and decrease in font size to “fit”.  </a:t>
+            </a:r>
+          </a:p>
+          <a:p>
+            <a:r>
+              <a:rPr lang="en-US" altLang="en-US" sz="2000" b="1" dirty="0"/>
+              <a:t>Need another Histogram?  Copy first one and change the data</a:t>
+            </a:r>
+          </a:p>
+          <a:p>
+            <a:r>
+              <a:rPr lang="en-US" altLang="en-US" sz="2000" dirty="0"/>
+              <a:t>You must create your own legend. Ungroup legend objects to edit text or color.</a:t>
+            </a:r>
+          </a:p>
+          <a:p>
+            <a:r>
+              <a:rPr lang="en-US" altLang="en-US" sz="2000" dirty="0"/>
+              <a:t>Colors and size are not standardized yet.</a:t>
+            </a:r>
+          </a:p>
+          <a:p>
+            <a:endParaRPr lang="en-US" altLang="en-US" sz="2000" dirty="0"/>
+          </a:p>
+          <a:p>
+            <a:endParaRPr lang="en-US" altLang="en-US" sz="2000" dirty="0"/>
+          </a:p>
+        </p:txBody>
+      </p:sp>
+      <p:sp>
+        <p:nvSpPr>
+          <p:cNvPr id="28675" name="Rectangle 3"/>
+          <p:cNvSpPr>
+            <a:spLocks noGrp="1" noRot="1" noChangeAspect="1" noChangeArrowheads="1"/>
+          </p:cNvSpPr>
+          <p:nvPr>
+            <p:ph type="sldImg"/>
+          </p:nvPr>
+        </p:nvSpPr>
+        <p:spPr bwMode="auto">
+          <a:xfrm>
+            <a:off x="393700" y="692150"/>
+            <a:ext cx="6070600" cy="3416300"/>
+          </a:xfrm>
+          <a:prstGeom prst="rect">
+            <a:avLst/>
+          </a:prstGeom>
+          <a:noFill/>
+          <a:ln w="12700" cap="flat">
+            <a:solidFill>
+              <a:schemeClr val="tx1"/>
+            </a:solidFill>
+            <a:miter lim="800000"/>
+            <a:headEnd/>
+            <a:tailEnd/>
+          </a:ln>
+          <a:extLst>
+            <a:ext uri="{909E8E84-426E-40DD-AFC4-6F175D3DCCD1}">
+              <a14:hiddenFill xmlns:a14="http://schemas.microsoft.com/office/drawing/2010/main">
+                <a:solidFill>
+                  <a:srgbClr val="FFFFFF"/>
+                </a:solidFill>
+              </a14:hiddenFill>
+            </a:ext>
+            <a:ext uri="{AF507438-7753-43E0-B8FC-AC1667EBCBE1}">
+              <a14:hiddenEffects xmlns:a14="http://schemas.microsoft.com/office/drawing/2010/main">
+                <a:effectLst>
+                  <a:outerShdw dist="35921" dir="2700000" algn="ctr" rotWithShape="0">
+                    <a:srgbClr val="808080"/>
+                  </a:outerShdw>
+                </a:effectLst>
+              </a14:hiddenEffects>
+            </a:ext>
+          </a:extLst>
+        </p:spPr>
+      </p:sp>
+    </p:spTree>
+    <p:extLst>
+      <p:ext uri="{BB962C8B-B14F-4D97-AF65-F5344CB8AC3E}">
+        <p14:creationId xmlns:p14="http://schemas.microsoft.com/office/powerpoint/2010/main" val="2207863968"/>
+      </p:ext>
+    </p:extLst>
+  </p:cSld>
+  <p:clrMapOvr>
+    <a:masterClrMapping/>
+  </p:clrMapOvr>
+</p:notes>
+</file>
+
+<file path=ppt/notesSlides/notesSlide4.xml><?xml version="1.0" encoding="utf-8"?>
+<p:notes xmlns:a="http://schemas.openxmlformats.org/drawingml/2006/main" xmlns:r="http://schemas.openxmlformats.org/officeDocument/2006/relationships" xmlns:p="http://schemas.openxmlformats.org/presentationml/2006/main">
+  <p:cSld>
+    <p:spTree>
+      <p:nvGrpSpPr>
+        <p:cNvPr id="1" name=""/>
+        <p:cNvGrpSpPr/>
+        <p:nvPr/>
+      </p:nvGrpSpPr>
+      <p:grpSpPr>
+        <a:xfrm>
+          <a:off x="0" y="0"/>
+          <a:ext cx="0" cy="0"/>
+          <a:chOff x="0" y="0"/>
+          <a:chExt cx="0" cy="0"/>
+        </a:xfrm>
+      </p:grpSpPr>
+      <p:sp>
+        <p:nvSpPr>
+          <p:cNvPr id="2" name="Slide Image Placeholder 1"/>
+          <p:cNvSpPr>
+            <a:spLocks noGrp="1" noRot="1" noChangeAspect="1"/>
+          </p:cNvSpPr>
+          <p:nvPr>
+            <p:ph type="sldImg"/>
+          </p:nvPr>
+        </p:nvSpPr>
+        <p:spPr/>
+      </p:sp>
+      <p:sp>
+        <p:nvSpPr>
+          <p:cNvPr id="3" name="Notes Placeholder 2"/>
+          <p:cNvSpPr>
+            <a:spLocks noGrp="1"/>
+          </p:cNvSpPr>
+          <p:nvPr>
+            <p:ph type="body" idx="1"/>
+          </p:nvPr>
+        </p:nvSpPr>
+        <p:spPr/>
+        <p:txBody>
+          <a:bodyPr/>
+          <a:lstStyle/>
+          <a:p>
+            <a:r>
+              <a:rPr lang="en-US" b="1" dirty="0"/>
+              <a:t>Extra slides that may or may not be used, don’t just delete!</a:t>
+            </a:r>
+          </a:p>
+        </p:txBody>
+      </p:sp>
+      <p:sp>
+        <p:nvSpPr>
+          <p:cNvPr id="4" name="Slide Number Placeholder 3"/>
+          <p:cNvSpPr>
+            <a:spLocks noGrp="1"/>
+          </p:cNvSpPr>
+          <p:nvPr>
+            <p:ph type="sldNum" sz="quarter" idx="5"/>
+          </p:nvPr>
+        </p:nvSpPr>
+        <p:spPr/>
+        <p:txBody>
+          <a:bodyPr/>
+          <a:lstStyle/>
+          <a:p>
+            <a:fld id="{98DB9D90-18B0-4CF8-86DE-169EA001EB17}" type="slidenum">
+              <a:rPr lang="en-US" altLang="en-US" smtClean="0"/>
+              <a:pPr/>
+              <a:t>15</a:t>
+            </a:fld>
+            <a:endParaRPr lang="en-US" altLang="en-US"/>
+          </a:p>
+        </p:txBody>
+      </p:sp>
+    </p:spTree>
+    <p:extLst>
+      <p:ext uri="{BB962C8B-B14F-4D97-AF65-F5344CB8AC3E}">
+        <p14:creationId xmlns:p14="http://schemas.microsoft.com/office/powerpoint/2010/main" val="2193846798"/>
+      </p:ext>
+    </p:extLst>
+  </p:cSld>
+  <p:clrMapOvr>
+    <a:masterClrMapping/>
+  </p:clrMapOvr>
+</p:notes>
 </file>
 
 <file path=ppt/slideLayouts/slideLayout1.xml><?xml version="1.0" encoding="utf-8"?>
@@ -287,11 +1474,6 @@
             <a:srgbClr val="FBAE40"/>
           </p15:clr>
         </p15:guide>
-        <p15:guide id="3" orient="horz" pos="2304" userDrawn="1">
-          <p15:clr>
-            <a:srgbClr val="FBAE40"/>
-          </p15:clr>
-        </p15:guide>
       </p15:sldGuideLst>
     </p:ext>
   </p:extLst>
@@ -411,11 +1593,6 @@
           </p15:clr>
         </p15:guide>
         <p15:guide id="2" pos="3840" userDrawn="1">
-          <p15:clr>
-            <a:srgbClr val="FBAE40"/>
-          </p15:clr>
-        </p15:guide>
-        <p15:guide id="3" orient="horz" pos="576" userDrawn="1">
           <p15:clr>
             <a:srgbClr val="FBAE40"/>
           </p15:clr>
@@ -656,11 +1833,6 @@
             <a:srgbClr val="FBAE40"/>
           </p15:clr>
         </p15:guide>
-        <p15:guide id="3" orient="horz" pos="576" userDrawn="1">
-          <p15:clr>
-            <a:srgbClr val="FBAE40"/>
-          </p15:clr>
-        </p15:guide>
       </p15:sldGuideLst>
     </p:ext>
   </p:extLst>
@@ -716,22 +1888,6 @@
   <p:clrMapOvr>
     <a:masterClrMapping/>
   </p:clrMapOvr>
-  <p:extLst>
-    <p:ext uri="{DCECCB84-F9BA-43D5-87BE-67443E8EF086}">
-      <p15:sldGuideLst xmlns:p15="http://schemas.microsoft.com/office/powerpoint/2012/main">
-        <p15:guide id="1" orient="horz" pos="2160" userDrawn="1">
-          <p15:clr>
-            <a:srgbClr val="FBAE40"/>
-          </p15:clr>
-        </p15:guide>
-        <p15:guide id="2" orient="horz" pos="576" userDrawn="1">
-          <p15:clr>
-            <a:srgbClr val="FBAE40"/>
-          </p15:clr>
-        </p15:guide>
-      </p15:sldGuideLst>
-    </p:ext>
-  </p:extLst>
 </p:sldLayout>
 </file>
 
@@ -835,6 +1991,176 @@
       </p15:sldGuideLst>
     </p:ext>
   </p:extLst>
+</p:sldLayout>
+</file>
+
+<file path=ppt/slideLayouts/slideLayout7.xml><?xml version="1.0" encoding="utf-8"?>
+<p:sldLayout xmlns:a="http://schemas.openxmlformats.org/drawingml/2006/main" xmlns:r="http://schemas.openxmlformats.org/officeDocument/2006/relationships" xmlns:p="http://schemas.openxmlformats.org/presentationml/2006/main" type="tbl">
+  <p:cSld name="Title and Table">
+    <p:spTree>
+      <p:nvGrpSpPr>
+        <p:cNvPr id="1" name=""/>
+        <p:cNvGrpSpPr/>
+        <p:nvPr/>
+      </p:nvGrpSpPr>
+      <p:grpSpPr>
+        <a:xfrm>
+          <a:off x="0" y="0"/>
+          <a:ext cx="0" cy="0"/>
+          <a:chOff x="0" y="0"/>
+          <a:chExt cx="0" cy="0"/>
+        </a:xfrm>
+      </p:grpSpPr>
+      <p:sp>
+        <p:nvSpPr>
+          <p:cNvPr id="2" name="Title 1"/>
+          <p:cNvSpPr>
+            <a:spLocks noGrp="1"/>
+          </p:cNvSpPr>
+          <p:nvPr>
+            <p:ph type="title"/>
+          </p:nvPr>
+        </p:nvSpPr>
+        <p:spPr>
+          <a:xfrm>
+            <a:off x="203200" y="76200"/>
+            <a:ext cx="11785600" cy="1143000"/>
+          </a:xfrm>
+        </p:spPr>
+        <p:txBody>
+          <a:bodyPr/>
+          <a:lstStyle/>
+          <a:p>
+            <a:r>
+              <a:rPr lang="en-US"/>
+              <a:t>Click to edit Master title style</a:t>
+            </a:r>
+          </a:p>
+        </p:txBody>
+      </p:sp>
+      <p:sp>
+        <p:nvSpPr>
+          <p:cNvPr id="3" name="Table Placeholder 2"/>
+          <p:cNvSpPr>
+            <a:spLocks noGrp="1"/>
+          </p:cNvSpPr>
+          <p:nvPr>
+            <p:ph type="tbl" idx="1"/>
+          </p:nvPr>
+        </p:nvSpPr>
+        <p:spPr>
+          <a:xfrm>
+            <a:off x="914400" y="1447800"/>
+            <a:ext cx="10363200" cy="5105400"/>
+          </a:xfrm>
+        </p:spPr>
+        <p:txBody>
+          <a:bodyPr/>
+          <a:lstStyle/>
+          <a:p>
+            <a:pPr lvl="0"/>
+            <a:r>
+              <a:rPr lang="en-US" noProof="0"/>
+              <a:t>Click icon to add table</a:t>
+            </a:r>
+          </a:p>
+        </p:txBody>
+      </p:sp>
+    </p:spTree>
+    <p:extLst>
+      <p:ext uri="{BB962C8B-B14F-4D97-AF65-F5344CB8AC3E}">
+        <p14:creationId xmlns:p14="http://schemas.microsoft.com/office/powerpoint/2010/main" val="3702153192"/>
+      </p:ext>
+    </p:extLst>
+  </p:cSld>
+  <p:clrMapOvr>
+    <a:masterClrMapping/>
+  </p:clrMapOvr>
+</p:sldLayout>
+</file>
+
+<file path=ppt/slideLayouts/slideLayout8.xml><?xml version="1.0" encoding="utf-8"?>
+<p:sldLayout xmlns:a="http://schemas.openxmlformats.org/drawingml/2006/main" xmlns:r="http://schemas.openxmlformats.org/officeDocument/2006/relationships" xmlns:p="http://schemas.openxmlformats.org/presentationml/2006/main" type="chart">
+  <p:cSld name="Title and Chart">
+    <p:spTree>
+      <p:nvGrpSpPr>
+        <p:cNvPr id="1" name=""/>
+        <p:cNvGrpSpPr/>
+        <p:nvPr/>
+      </p:nvGrpSpPr>
+      <p:grpSpPr>
+        <a:xfrm>
+          <a:off x="0" y="0"/>
+          <a:ext cx="0" cy="0"/>
+          <a:chOff x="0" y="0"/>
+          <a:chExt cx="0" cy="0"/>
+        </a:xfrm>
+      </p:grpSpPr>
+      <p:sp>
+        <p:nvSpPr>
+          <p:cNvPr id="2" name="Title 1"/>
+          <p:cNvSpPr>
+            <a:spLocks noGrp="1"/>
+          </p:cNvSpPr>
+          <p:nvPr>
+            <p:ph type="title"/>
+          </p:nvPr>
+        </p:nvSpPr>
+        <p:spPr>
+          <a:xfrm>
+            <a:off x="203200" y="76200"/>
+            <a:ext cx="11785600" cy="1143000"/>
+          </a:xfrm>
+        </p:spPr>
+        <p:txBody>
+          <a:bodyPr/>
+          <a:lstStyle/>
+          <a:p>
+            <a:r>
+              <a:rPr lang="en-US"/>
+              <a:t>Click to edit Master title style</a:t>
+            </a:r>
+          </a:p>
+        </p:txBody>
+      </p:sp>
+      <p:sp>
+        <p:nvSpPr>
+          <p:cNvPr id="3" name="Chart Placeholder 2"/>
+          <p:cNvSpPr>
+            <a:spLocks noGrp="1"/>
+          </p:cNvSpPr>
+          <p:nvPr>
+            <p:ph type="chart" idx="1"/>
+          </p:nvPr>
+        </p:nvSpPr>
+        <p:spPr>
+          <a:xfrm>
+            <a:off x="914400" y="1447800"/>
+            <a:ext cx="10363200" cy="5105400"/>
+          </a:xfrm>
+        </p:spPr>
+        <p:txBody>
+          <a:bodyPr/>
+          <a:lstStyle/>
+          <a:p>
+            <a:pPr lvl="0"/>
+            <a:r>
+              <a:rPr lang="en-US" noProof="0"/>
+              <a:t>Click icon to add chart</a:t>
+            </a:r>
+          </a:p>
+        </p:txBody>
+      </p:sp>
+    </p:spTree>
+    <p:extLst>
+      <p:ext uri="{BB962C8B-B14F-4D97-AF65-F5344CB8AC3E}">
+        <p14:creationId xmlns:p14="http://schemas.microsoft.com/office/powerpoint/2010/main" val="1866274064"/>
+      </p:ext>
+    </p:extLst>
+  </p:cSld>
+  <p:clrMapOvr>
+    <a:masterClrMapping/>
+  </p:clrMapOvr>
 </p:sldLayout>
 </file>
 
@@ -1038,6 +2364,8 @@
     <p:sldLayoutId id="2147484307" r:id="rId4"/>
     <p:sldLayoutId id="2147484309" r:id="rId5"/>
     <p:sldLayoutId id="2147484308" r:id="rId6"/>
+    <p:sldLayoutId id="2147484310" r:id="rId7"/>
+    <p:sldLayoutId id="2147484311" r:id="rId8"/>
   </p:sldLayoutIdLst>
   <p:txStyles>
     <p:titleStyle>
@@ -1458,11 +2786,6 @@
           </p15:clr>
         </p15:guide>
         <p15:guide id="2" pos="3840" userDrawn="1">
-          <p15:clr>
-            <a:srgbClr val="F26B43"/>
-          </p15:clr>
-        </p15:guide>
-        <p15:guide id="3" orient="horz" pos="552" userDrawn="1">
           <p15:clr>
             <a:srgbClr val="F26B43"/>
           </p15:clr>
@@ -1984,4 +3307,762 @@
     </a:extraClrScheme>
   </a:extraClrSchemeLst>
 </a:theme>
+</file>
+
+<file path=ppt/theme/theme2.xml><?xml version="1.0" encoding="utf-8"?>
+<a:theme xmlns:a="http://schemas.openxmlformats.org/drawingml/2006/main" name="Office Theme">
+  <a:themeElements>
+    <a:clrScheme name="">
+      <a:dk1>
+        <a:srgbClr val="000000"/>
+      </a:dk1>
+      <a:lt1>
+        <a:srgbClr val="FFFFFF"/>
+      </a:lt1>
+      <a:dk2>
+        <a:srgbClr val="000000"/>
+      </a:dk2>
+      <a:lt2>
+        <a:srgbClr val="808080"/>
+      </a:lt2>
+      <a:accent1>
+        <a:srgbClr val="00CC99"/>
+      </a:accent1>
+      <a:accent2>
+        <a:srgbClr val="3333CC"/>
+      </a:accent2>
+      <a:accent3>
+        <a:srgbClr val="FFFFFF"/>
+      </a:accent3>
+      <a:accent4>
+        <a:srgbClr val="000000"/>
+      </a:accent4>
+      <a:accent5>
+        <a:srgbClr val="AAE2CA"/>
+      </a:accent5>
+      <a:accent6>
+        <a:srgbClr val="2D2DB9"/>
+      </a:accent6>
+      <a:hlink>
+        <a:srgbClr val="CCCCFF"/>
+      </a:hlink>
+      <a:folHlink>
+        <a:srgbClr val="B2B2B2"/>
+      </a:folHlink>
+    </a:clrScheme>
+    <a:fontScheme name="Office">
+      <a:majorFont>
+        <a:latin typeface="Calibri"/>
+        <a:ea typeface=""/>
+        <a:cs typeface=""/>
+        <a:font script="Jpan" typeface="ＭＳ Ｐゴシック"/>
+        <a:font script="Hang" typeface="맑은 고딕"/>
+        <a:font script="Hans" typeface="宋体"/>
+        <a:font script="Hant" typeface="新細明體"/>
+        <a:font script="Arab" typeface="Times New Roman"/>
+        <a:font script="Hebr" typeface="Times New Roman"/>
+        <a:font script="Thai" typeface="Angsana New"/>
+        <a:font script="Ethi" typeface="Nyala"/>
+        <a:font script="Beng" typeface="Vrinda"/>
+        <a:font script="Gujr" typeface="Shruti"/>
+        <a:font script="Khmr" typeface="MoolBoran"/>
+        <a:font script="Knda" typeface="Tunga"/>
+        <a:font script="Guru" typeface="Raavi"/>
+        <a:font script="Cans" typeface="Euphemia"/>
+        <a:font script="Cher" typeface="Plantagenet Cherokee"/>
+        <a:font script="Yiii" typeface="Microsoft Yi Baiti"/>
+        <a:font script="Tibt" typeface="Microsoft Himalaya"/>
+        <a:font script="Thaa" typeface="MV Boli"/>
+        <a:font script="Deva" typeface="Mangal"/>
+        <a:font script="Telu" typeface="Gautami"/>
+        <a:font script="Taml" typeface="Latha"/>
+        <a:font script="Syrc" typeface="Estrangelo Edessa"/>
+        <a:font script="Orya" typeface="Kalinga"/>
+        <a:font script="Mlym" typeface="Kartika"/>
+        <a:font script="Laoo" typeface="DokChampa"/>
+        <a:font script="Sinh" typeface="Iskoola Pota"/>
+        <a:font script="Mong" typeface="Mongolian Baiti"/>
+        <a:font script="Viet" typeface="Times New Roman"/>
+        <a:font script="Uigh" typeface="Microsoft Uighur"/>
+      </a:majorFont>
+      <a:minorFont>
+        <a:latin typeface="Calibri"/>
+        <a:ea typeface=""/>
+        <a:cs typeface=""/>
+        <a:font script="Jpan" typeface="ＭＳ Ｐゴシック"/>
+        <a:font script="Hang" typeface="맑은 고딕"/>
+        <a:font script="Hans" typeface="宋体"/>
+        <a:font script="Hant" typeface="新細明體"/>
+        <a:font script="Arab" typeface="Arial"/>
+        <a:font script="Hebr" typeface="Arial"/>
+        <a:font script="Thai" typeface="Cordia New"/>
+        <a:font script="Ethi" typeface="Nyala"/>
+        <a:font script="Beng" typeface="Vrinda"/>
+        <a:font script="Gujr" typeface="Shruti"/>
+        <a:font script="Khmr" typeface="DaunPenh"/>
+        <a:font script="Knda" typeface="Tunga"/>
+        <a:font script="Guru" typeface="Raavi"/>
+        <a:font script="Cans" typeface="Euphemia"/>
+        <a:font script="Cher" typeface="Plantagenet Cherokee"/>
+        <a:font script="Yiii" typeface="Microsoft Yi Baiti"/>
+        <a:font script="Tibt" typeface="Microsoft Himalaya"/>
+        <a:font script="Thaa" typeface="MV Boli"/>
+        <a:font script="Deva" typeface="Mangal"/>
+        <a:font script="Telu" typeface="Gautami"/>
+        <a:font script="Taml" typeface="Latha"/>
+        <a:font script="Syrc" typeface="Estrangelo Edessa"/>
+        <a:font script="Orya" typeface="Kalinga"/>
+        <a:font script="Mlym" typeface="Kartika"/>
+        <a:font script="Laoo" typeface="DokChampa"/>
+        <a:font script="Sinh" typeface="Iskoola Pota"/>
+        <a:font script="Mong" typeface="Mongolian Baiti"/>
+        <a:font script="Viet" typeface="Arial"/>
+        <a:font script="Uigh" typeface="Microsoft Uighur"/>
+      </a:minorFont>
+    </a:fontScheme>
+    <a:fmtScheme name="Office">
+      <a:fillStyleLst>
+        <a:solidFill>
+          <a:schemeClr val="phClr"/>
+        </a:solidFill>
+        <a:gradFill rotWithShape="1">
+          <a:gsLst>
+            <a:gs pos="0">
+              <a:schemeClr val="phClr">
+                <a:tint val="50000"/>
+                <a:satMod val="300000"/>
+              </a:schemeClr>
+            </a:gs>
+            <a:gs pos="35000">
+              <a:schemeClr val="phClr">
+                <a:tint val="37000"/>
+                <a:satMod val="300000"/>
+              </a:schemeClr>
+            </a:gs>
+            <a:gs pos="100000">
+              <a:schemeClr val="phClr">
+                <a:tint val="15000"/>
+                <a:satMod val="350000"/>
+              </a:schemeClr>
+            </a:gs>
+          </a:gsLst>
+          <a:lin ang="16200000" scaled="1"/>
+        </a:gradFill>
+        <a:gradFill rotWithShape="1">
+          <a:gsLst>
+            <a:gs pos="0">
+              <a:schemeClr val="phClr">
+                <a:shade val="51000"/>
+                <a:satMod val="130000"/>
+              </a:schemeClr>
+            </a:gs>
+            <a:gs pos="80000">
+              <a:schemeClr val="phClr">
+                <a:shade val="93000"/>
+                <a:satMod val="130000"/>
+              </a:schemeClr>
+            </a:gs>
+            <a:gs pos="100000">
+              <a:schemeClr val="phClr">
+                <a:shade val="94000"/>
+                <a:satMod val="135000"/>
+              </a:schemeClr>
+            </a:gs>
+          </a:gsLst>
+          <a:lin ang="16200000" scaled="0"/>
+        </a:gradFill>
+      </a:fillStyleLst>
+      <a:lnStyleLst>
+        <a:ln w="9525" cap="flat" cmpd="sng" algn="ctr">
+          <a:solidFill>
+            <a:schemeClr val="phClr">
+              <a:shade val="95000"/>
+              <a:satMod val="105000"/>
+            </a:schemeClr>
+          </a:solidFill>
+          <a:prstDash val="solid"/>
+        </a:ln>
+        <a:ln w="25400" cap="flat" cmpd="sng" algn="ctr">
+          <a:solidFill>
+            <a:schemeClr val="phClr"/>
+          </a:solidFill>
+          <a:prstDash val="solid"/>
+        </a:ln>
+        <a:ln w="38100" cap="flat" cmpd="sng" algn="ctr">
+          <a:solidFill>
+            <a:schemeClr val="phClr"/>
+          </a:solidFill>
+          <a:prstDash val="solid"/>
+        </a:ln>
+      </a:lnStyleLst>
+      <a:effectStyleLst>
+        <a:effectStyle>
+          <a:effectLst>
+            <a:outerShdw blurRad="40000" dist="20000" dir="5400000" rotWithShape="0">
+              <a:srgbClr val="000000">
+                <a:alpha val="38000"/>
+              </a:srgbClr>
+            </a:outerShdw>
+          </a:effectLst>
+        </a:effectStyle>
+        <a:effectStyle>
+          <a:effectLst>
+            <a:outerShdw blurRad="40000" dist="23000" dir="5400000" rotWithShape="0">
+              <a:srgbClr val="000000">
+                <a:alpha val="35000"/>
+              </a:srgbClr>
+            </a:outerShdw>
+          </a:effectLst>
+        </a:effectStyle>
+        <a:effectStyle>
+          <a:effectLst>
+            <a:outerShdw blurRad="40000" dist="23000" dir="5400000" rotWithShape="0">
+              <a:srgbClr val="000000">
+                <a:alpha val="35000"/>
+              </a:srgbClr>
+            </a:outerShdw>
+          </a:effectLst>
+          <a:scene3d>
+            <a:camera prst="orthographicFront">
+              <a:rot lat="0" lon="0" rev="0"/>
+            </a:camera>
+            <a:lightRig rig="threePt" dir="t">
+              <a:rot lat="0" lon="0" rev="1200000"/>
+            </a:lightRig>
+          </a:scene3d>
+          <a:sp3d>
+            <a:bevelT w="63500" h="25400"/>
+          </a:sp3d>
+        </a:effectStyle>
+      </a:effectStyleLst>
+      <a:bgFillStyleLst>
+        <a:solidFill>
+          <a:schemeClr val="phClr"/>
+        </a:solidFill>
+        <a:gradFill rotWithShape="1">
+          <a:gsLst>
+            <a:gs pos="0">
+              <a:schemeClr val="phClr">
+                <a:tint val="40000"/>
+                <a:satMod val="350000"/>
+              </a:schemeClr>
+            </a:gs>
+            <a:gs pos="40000">
+              <a:schemeClr val="phClr">
+                <a:tint val="45000"/>
+                <a:shade val="99000"/>
+                <a:satMod val="350000"/>
+              </a:schemeClr>
+            </a:gs>
+            <a:gs pos="100000">
+              <a:schemeClr val="phClr">
+                <a:shade val="20000"/>
+                <a:satMod val="255000"/>
+              </a:schemeClr>
+            </a:gs>
+          </a:gsLst>
+          <a:path path="circle">
+            <a:fillToRect l="50000" t="-80000" r="50000" b="180000"/>
+          </a:path>
+        </a:gradFill>
+        <a:gradFill rotWithShape="1">
+          <a:gsLst>
+            <a:gs pos="0">
+              <a:schemeClr val="phClr">
+                <a:tint val="80000"/>
+                <a:satMod val="300000"/>
+              </a:schemeClr>
+            </a:gs>
+            <a:gs pos="100000">
+              <a:schemeClr val="phClr">
+                <a:shade val="30000"/>
+                <a:satMod val="200000"/>
+              </a:schemeClr>
+            </a:gs>
+          </a:gsLst>
+          <a:path path="circle">
+            <a:fillToRect l="50000" t="50000" r="50000" b="50000"/>
+          </a:path>
+        </a:gradFill>
+      </a:bgFillStyleLst>
+    </a:fmtScheme>
+  </a:themeElements>
+  <a:objectDefaults/>
+  <a:extraClrSchemeLst/>
+</a:theme>
+</file>
+
+<file path=ppt/theme/theme3.xml><?xml version="1.0" encoding="utf-8"?>
+<a:theme xmlns:a="http://schemas.openxmlformats.org/drawingml/2006/main" name="Office Theme">
+  <a:themeElements>
+    <a:clrScheme name="">
+      <a:dk1>
+        <a:srgbClr val="000000"/>
+      </a:dk1>
+      <a:lt1>
+        <a:srgbClr val="FFFFFF"/>
+      </a:lt1>
+      <a:dk2>
+        <a:srgbClr val="000000"/>
+      </a:dk2>
+      <a:lt2>
+        <a:srgbClr val="808080"/>
+      </a:lt2>
+      <a:accent1>
+        <a:srgbClr val="BBE0E3"/>
+      </a:accent1>
+      <a:accent2>
+        <a:srgbClr val="333399"/>
+      </a:accent2>
+      <a:accent3>
+        <a:srgbClr val="FFFFFF"/>
+      </a:accent3>
+      <a:accent4>
+        <a:srgbClr val="000000"/>
+      </a:accent4>
+      <a:accent5>
+        <a:srgbClr val="DAEDEF"/>
+      </a:accent5>
+      <a:accent6>
+        <a:srgbClr val="2D2D8A"/>
+      </a:accent6>
+      <a:hlink>
+        <a:srgbClr val="009999"/>
+      </a:hlink>
+      <a:folHlink>
+        <a:srgbClr val="99CC00"/>
+      </a:folHlink>
+    </a:clrScheme>
+    <a:fontScheme name="Office">
+      <a:majorFont>
+        <a:latin typeface="Calibri"/>
+        <a:ea typeface=""/>
+        <a:cs typeface=""/>
+        <a:font script="Jpan" typeface="ＭＳ Ｐゴシック"/>
+        <a:font script="Hang" typeface="맑은 고딕"/>
+        <a:font script="Hans" typeface="宋体"/>
+        <a:font script="Hant" typeface="新細明體"/>
+        <a:font script="Arab" typeface="Times New Roman"/>
+        <a:font script="Hebr" typeface="Times New Roman"/>
+        <a:font script="Thai" typeface="Angsana New"/>
+        <a:font script="Ethi" typeface="Nyala"/>
+        <a:font script="Beng" typeface="Vrinda"/>
+        <a:font script="Gujr" typeface="Shruti"/>
+        <a:font script="Khmr" typeface="MoolBoran"/>
+        <a:font script="Knda" typeface="Tunga"/>
+        <a:font script="Guru" typeface="Raavi"/>
+        <a:font script="Cans" typeface="Euphemia"/>
+        <a:font script="Cher" typeface="Plantagenet Cherokee"/>
+        <a:font script="Yiii" typeface="Microsoft Yi Baiti"/>
+        <a:font script="Tibt" typeface="Microsoft Himalaya"/>
+        <a:font script="Thaa" typeface="MV Boli"/>
+        <a:font script="Deva" typeface="Mangal"/>
+        <a:font script="Telu" typeface="Gautami"/>
+        <a:font script="Taml" typeface="Latha"/>
+        <a:font script="Syrc" typeface="Estrangelo Edessa"/>
+        <a:font script="Orya" typeface="Kalinga"/>
+        <a:font script="Mlym" typeface="Kartika"/>
+        <a:font script="Laoo" typeface="DokChampa"/>
+        <a:font script="Sinh" typeface="Iskoola Pota"/>
+        <a:font script="Mong" typeface="Mongolian Baiti"/>
+        <a:font script="Viet" typeface="Times New Roman"/>
+        <a:font script="Uigh" typeface="Microsoft Uighur"/>
+      </a:majorFont>
+      <a:minorFont>
+        <a:latin typeface="Calibri"/>
+        <a:ea typeface=""/>
+        <a:cs typeface=""/>
+        <a:font script="Jpan" typeface="ＭＳ Ｐゴシック"/>
+        <a:font script="Hang" typeface="맑은 고딕"/>
+        <a:font script="Hans" typeface="宋体"/>
+        <a:font script="Hant" typeface="新細明體"/>
+        <a:font script="Arab" typeface="Arial"/>
+        <a:font script="Hebr" typeface="Arial"/>
+        <a:font script="Thai" typeface="Cordia New"/>
+        <a:font script="Ethi" typeface="Nyala"/>
+        <a:font script="Beng" typeface="Vrinda"/>
+        <a:font script="Gujr" typeface="Shruti"/>
+        <a:font script="Khmr" typeface="DaunPenh"/>
+        <a:font script="Knda" typeface="Tunga"/>
+        <a:font script="Guru" typeface="Raavi"/>
+        <a:font script="Cans" typeface="Euphemia"/>
+        <a:font script="Cher" typeface="Plantagenet Cherokee"/>
+        <a:font script="Yiii" typeface="Microsoft Yi Baiti"/>
+        <a:font script="Tibt" typeface="Microsoft Himalaya"/>
+        <a:font script="Thaa" typeface="MV Boli"/>
+        <a:font script="Deva" typeface="Mangal"/>
+        <a:font script="Telu" typeface="Gautami"/>
+        <a:font script="Taml" typeface="Latha"/>
+        <a:font script="Syrc" typeface="Estrangelo Edessa"/>
+        <a:font script="Orya" typeface="Kalinga"/>
+        <a:font script="Mlym" typeface="Kartika"/>
+        <a:font script="Laoo" typeface="DokChampa"/>
+        <a:font script="Sinh" typeface="Iskoola Pota"/>
+        <a:font script="Mong" typeface="Mongolian Baiti"/>
+        <a:font script="Viet" typeface="Arial"/>
+        <a:font script="Uigh" typeface="Microsoft Uighur"/>
+      </a:minorFont>
+    </a:fontScheme>
+    <a:fmtScheme name="Office">
+      <a:fillStyleLst>
+        <a:solidFill>
+          <a:schemeClr val="phClr"/>
+        </a:solidFill>
+        <a:gradFill rotWithShape="1">
+          <a:gsLst>
+            <a:gs pos="0">
+              <a:schemeClr val="phClr">
+                <a:tint val="50000"/>
+                <a:satMod val="300000"/>
+              </a:schemeClr>
+            </a:gs>
+            <a:gs pos="35000">
+              <a:schemeClr val="phClr">
+                <a:tint val="37000"/>
+                <a:satMod val="300000"/>
+              </a:schemeClr>
+            </a:gs>
+            <a:gs pos="100000">
+              <a:schemeClr val="phClr">
+                <a:tint val="15000"/>
+                <a:satMod val="350000"/>
+              </a:schemeClr>
+            </a:gs>
+          </a:gsLst>
+          <a:lin ang="16200000" scaled="1"/>
+        </a:gradFill>
+        <a:gradFill rotWithShape="1">
+          <a:gsLst>
+            <a:gs pos="0">
+              <a:schemeClr val="phClr">
+                <a:shade val="51000"/>
+                <a:satMod val="130000"/>
+              </a:schemeClr>
+            </a:gs>
+            <a:gs pos="80000">
+              <a:schemeClr val="phClr">
+                <a:shade val="93000"/>
+                <a:satMod val="130000"/>
+              </a:schemeClr>
+            </a:gs>
+            <a:gs pos="100000">
+              <a:schemeClr val="phClr">
+                <a:shade val="94000"/>
+                <a:satMod val="135000"/>
+              </a:schemeClr>
+            </a:gs>
+          </a:gsLst>
+          <a:lin ang="16200000" scaled="0"/>
+        </a:gradFill>
+      </a:fillStyleLst>
+      <a:lnStyleLst>
+        <a:ln w="9525" cap="flat" cmpd="sng" algn="ctr">
+          <a:solidFill>
+            <a:schemeClr val="phClr">
+              <a:shade val="95000"/>
+              <a:satMod val="105000"/>
+            </a:schemeClr>
+          </a:solidFill>
+          <a:prstDash val="solid"/>
+        </a:ln>
+        <a:ln w="25400" cap="flat" cmpd="sng" algn="ctr">
+          <a:solidFill>
+            <a:schemeClr val="phClr"/>
+          </a:solidFill>
+          <a:prstDash val="solid"/>
+        </a:ln>
+        <a:ln w="38100" cap="flat" cmpd="sng" algn="ctr">
+          <a:solidFill>
+            <a:schemeClr val="phClr"/>
+          </a:solidFill>
+          <a:prstDash val="solid"/>
+        </a:ln>
+      </a:lnStyleLst>
+      <a:effectStyleLst>
+        <a:effectStyle>
+          <a:effectLst>
+            <a:outerShdw blurRad="40000" dist="20000" dir="5400000" rotWithShape="0">
+              <a:srgbClr val="000000">
+                <a:alpha val="38000"/>
+              </a:srgbClr>
+            </a:outerShdw>
+          </a:effectLst>
+        </a:effectStyle>
+        <a:effectStyle>
+          <a:effectLst>
+            <a:outerShdw blurRad="40000" dist="23000" dir="5400000" rotWithShape="0">
+              <a:srgbClr val="000000">
+                <a:alpha val="35000"/>
+              </a:srgbClr>
+            </a:outerShdw>
+          </a:effectLst>
+        </a:effectStyle>
+        <a:effectStyle>
+          <a:effectLst>
+            <a:outerShdw blurRad="40000" dist="23000" dir="5400000" rotWithShape="0">
+              <a:srgbClr val="000000">
+                <a:alpha val="35000"/>
+              </a:srgbClr>
+            </a:outerShdw>
+          </a:effectLst>
+          <a:scene3d>
+            <a:camera prst="orthographicFront">
+              <a:rot lat="0" lon="0" rev="0"/>
+            </a:camera>
+            <a:lightRig rig="threePt" dir="t">
+              <a:rot lat="0" lon="0" rev="1200000"/>
+            </a:lightRig>
+          </a:scene3d>
+          <a:sp3d>
+            <a:bevelT w="63500" h="25400"/>
+          </a:sp3d>
+        </a:effectStyle>
+      </a:effectStyleLst>
+      <a:bgFillStyleLst>
+        <a:solidFill>
+          <a:schemeClr val="phClr"/>
+        </a:solidFill>
+        <a:gradFill rotWithShape="1">
+          <a:gsLst>
+            <a:gs pos="0">
+              <a:schemeClr val="phClr">
+                <a:tint val="40000"/>
+                <a:satMod val="350000"/>
+              </a:schemeClr>
+            </a:gs>
+            <a:gs pos="40000">
+              <a:schemeClr val="phClr">
+                <a:tint val="45000"/>
+                <a:shade val="99000"/>
+                <a:satMod val="350000"/>
+              </a:schemeClr>
+            </a:gs>
+            <a:gs pos="100000">
+              <a:schemeClr val="phClr">
+                <a:shade val="20000"/>
+                <a:satMod val="255000"/>
+              </a:schemeClr>
+            </a:gs>
+          </a:gsLst>
+          <a:path path="circle">
+            <a:fillToRect l="50000" t="-80000" r="50000" b="180000"/>
+          </a:path>
+        </a:gradFill>
+        <a:gradFill rotWithShape="1">
+          <a:gsLst>
+            <a:gs pos="0">
+              <a:schemeClr val="phClr">
+                <a:tint val="80000"/>
+                <a:satMod val="300000"/>
+              </a:schemeClr>
+            </a:gs>
+            <a:gs pos="100000">
+              <a:schemeClr val="phClr">
+                <a:shade val="30000"/>
+                <a:satMod val="200000"/>
+              </a:schemeClr>
+            </a:gs>
+          </a:gsLst>
+          <a:path path="circle">
+            <a:fillToRect l="50000" t="50000" r="50000" b="50000"/>
+          </a:path>
+        </a:gradFill>
+      </a:bgFillStyleLst>
+    </a:fmtScheme>
+  </a:themeElements>
+  <a:objectDefaults/>
+  <a:extraClrSchemeLst/>
+</a:theme>
+</file>
+
+<file path=customXml/item1.xml><?xml version="1.0" encoding="utf-8"?>
+<ct:contentTypeSchema xmlns:ct="http://schemas.microsoft.com/office/2006/metadata/contentType" xmlns:ma="http://schemas.microsoft.com/office/2006/metadata/properties/metaAttributes" ct:_="" ma:_="" ma:contentTypeName="Document" ma:contentTypeID="0x0101003257C9AA676C6D4F9955D058A3DEAB7D" ma:contentTypeVersion="4" ma:contentTypeDescription="Create a new document." ma:contentTypeScope="" ma:versionID="a7d3c64abb7d8f874e738ce039843625">
+  <xsd:schema xmlns:xsd="http://www.w3.org/2001/XMLSchema" xmlns:xs="http://www.w3.org/2001/XMLSchema" xmlns:p="http://schemas.microsoft.com/office/2006/metadata/properties" xmlns:ns2="ee4fc995-f6d0-4bc8-8771-94b803449598" targetNamespace="http://schemas.microsoft.com/office/2006/metadata/properties" ma:root="true" ma:fieldsID="71c8a9e5b3745e4cc6bcbcaf208c951d" ns2:_="">
+    <xsd:import namespace="ee4fc995-f6d0-4bc8-8771-94b803449598"/>
+    <xsd:element name="properties">
+      <xsd:complexType>
+        <xsd:sequence>
+          <xsd:element name="documentManagement">
+            <xsd:complexType>
+              <xsd:all>
+                <xsd:element ref="ns2:MediaServiceMetadata" minOccurs="0"/>
+                <xsd:element ref="ns2:MediaServiceFastMetadata" minOccurs="0"/>
+                <xsd:element ref="ns2:MediaServiceSearchProperties" minOccurs="0"/>
+                <xsd:element ref="ns2:TemplateDescription" minOccurs="0"/>
+              </xsd:all>
+            </xsd:complexType>
+          </xsd:element>
+        </xsd:sequence>
+      </xsd:complexType>
+    </xsd:element>
+  </xsd:schema>
+  <xsd:schema xmlns:xsd="http://www.w3.org/2001/XMLSchema" xmlns:xs="http://www.w3.org/2001/XMLSchema" xmlns:dms="http://schemas.microsoft.com/office/2006/documentManagement/types" xmlns:pc="http://schemas.microsoft.com/office/infopath/2007/PartnerControls" targetNamespace="ee4fc995-f6d0-4bc8-8771-94b803449598" elementFormDefault="qualified">
+    <xsd:import namespace="http://schemas.microsoft.com/office/2006/documentManagement/types"/>
+    <xsd:import namespace="http://schemas.microsoft.com/office/infopath/2007/PartnerControls"/>
+    <xsd:element name="MediaServiceMetadata" ma:index="8" nillable="true" ma:displayName="MediaServiceMetadata" ma:hidden="true" ma:internalName="MediaServiceMetadata" ma:readOnly="true">
+      <xsd:simpleType>
+        <xsd:restriction base="dms:Note"/>
+      </xsd:simpleType>
+    </xsd:element>
+    <xsd:element name="MediaServiceFastMetadata" ma:index="9" nillable="true" ma:displayName="MediaServiceFastMetadata" ma:hidden="true" ma:internalName="MediaServiceFastMetadata" ma:readOnly="true">
+      <xsd:simpleType>
+        <xsd:restriction base="dms:Note"/>
+      </xsd:simpleType>
+    </xsd:element>
+    <xsd:element name="MediaServiceSearchProperties" ma:index="10" nillable="true" ma:displayName="MediaServiceSearchProperties" ma:hidden="true" ma:internalName="MediaServiceSearchProperties" ma:readOnly="true">
+      <xsd:simpleType>
+        <xsd:restriction base="dms:Note"/>
+      </xsd:simpleType>
+    </xsd:element>
+    <xsd:element name="TemplateDescription" ma:index="11" nillable="true" ma:displayName="Template Description" ma:description="What is this for." ma:format="Dropdown" ma:internalName="TemplateDescription">
+      <xsd:simpleType>
+        <xsd:restriction base="dms:Text">
+          <xsd:maxLength value="255"/>
+        </xsd:restriction>
+      </xsd:simpleType>
+    </xsd:element>
+  </xsd:schema>
+  <xsd:schema xmlns="http://schemas.openxmlformats.org/package/2006/metadata/core-properties" xmlns:xsd="http://www.w3.org/2001/XMLSchema" xmlns:xsi="http://www.w3.org/2001/XMLSchema-instance" xmlns:dc="http://purl.org/dc/elements/1.1/" xmlns:dcterms="http://purl.org/dc/terms/" xmlns:odoc="http://schemas.microsoft.com/internal/obd" targetNamespace="http://schemas.openxmlformats.org/package/2006/metadata/core-properties" elementFormDefault="qualified" attributeFormDefault="unqualified" blockDefault="#all">
+    <xsd:import namespace="http://purl.org/dc/elements/1.1/" schemaLocation="http://dublincore.org/schemas/xmls/qdc/2003/04/02/dc.xsd"/>
+    <xsd:import namespace="http://purl.org/dc/terms/" schemaLocation="http://dublincore.org/schemas/xmls/qdc/2003/04/02/dcterms.xsd"/>
+    <xsd:element name="coreProperties" type="CT_coreProperties"/>
+    <xsd:complexType name="CT_coreProperties">
+      <xsd:all>
+        <xsd:element ref="dc:creator" minOccurs="0" maxOccurs="1"/>
+        <xsd:element ref="dcterms:created" minOccurs="0" maxOccurs="1"/>
+        <xsd:element ref="dc:identifier" minOccurs="0" maxOccurs="1"/>
+        <xsd:element name="contentType" minOccurs="0" maxOccurs="1" type="xsd:string" ma:index="0" ma:displayName="Content Type"/>
+        <xsd:element ref="dc:title" minOccurs="0" maxOccurs="1" ma:index="4" ma:displayName="Title"/>
+        <xsd:element ref="dc:subject" minOccurs="0" maxOccurs="1"/>
+        <xsd:element ref="dc:description" minOccurs="0" maxOccurs="1"/>
+        <xsd:element name="keywords" minOccurs="0" maxOccurs="1" type="xsd:string"/>
+        <xsd:element ref="dc:language" minOccurs="0" maxOccurs="1"/>
+        <xsd:element name="category" minOccurs="0" maxOccurs="1" type="xsd:string"/>
+        <xsd:element name="version" minOccurs="0" maxOccurs="1" type="xsd:string"/>
+        <xsd:element name="revision" minOccurs="0" maxOccurs="1" type="xsd:string">
+          <xsd:annotation>
+            <xsd:documentation>
+                        This value indicates the number of saves or revisions. The application is responsible for updating this value after each revision.
+                    </xsd:documentation>
+          </xsd:annotation>
+        </xsd:element>
+        <xsd:element name="lastModifiedBy" minOccurs="0" maxOccurs="1" type="xsd:string"/>
+        <xsd:element ref="dcterms:modified" minOccurs="0" maxOccurs="1"/>
+        <xsd:element name="contentStatus" minOccurs="0" maxOccurs="1" type="xsd:string"/>
+      </xsd:all>
+    </xsd:complexType>
+  </xsd:schema>
+  <xs:schema xmlns:pc="http://schemas.microsoft.com/office/infopath/2007/PartnerControls" xmlns:xs="http://www.w3.org/2001/XMLSchema" targetNamespace="http://schemas.microsoft.com/office/infopath/2007/PartnerControls" elementFormDefault="qualified" attributeFormDefault="unqualified">
+    <xs:element name="Person">
+      <xs:complexType>
+        <xs:sequence>
+          <xs:element ref="pc:DisplayName" minOccurs="0"/>
+          <xs:element ref="pc:AccountId" minOccurs="0"/>
+          <xs:element ref="pc:AccountType" minOccurs="0"/>
+        </xs:sequence>
+      </xs:complexType>
+    </xs:element>
+    <xs:element name="DisplayName" type="xs:string"/>
+    <xs:element name="AccountId" type="xs:string"/>
+    <xs:element name="AccountType" type="xs:string"/>
+    <xs:element name="BDCAssociatedEntity">
+      <xs:complexType>
+        <xs:sequence>
+          <xs:element ref="pc:BDCEntity" minOccurs="0" maxOccurs="unbounded"/>
+        </xs:sequence>
+        <xs:attribute ref="pc:EntityNamespace"/>
+        <xs:attribute ref="pc:EntityName"/>
+        <xs:attribute ref="pc:SystemInstanceName"/>
+        <xs:attribute ref="pc:AssociationName"/>
+      </xs:complexType>
+    </xs:element>
+    <xs:attribute name="EntityNamespace" type="xs:string"/>
+    <xs:attribute name="EntityName" type="xs:string"/>
+    <xs:attribute name="SystemInstanceName" type="xs:string"/>
+    <xs:attribute name="AssociationName" type="xs:string"/>
+    <xs:element name="BDCEntity">
+      <xs:complexType>
+        <xs:sequence>
+          <xs:element ref="pc:EntityDisplayName" minOccurs="0"/>
+          <xs:element ref="pc:EntityInstanceReference" minOccurs="0"/>
+          <xs:element ref="pc:EntityId1" minOccurs="0"/>
+          <xs:element ref="pc:EntityId2" minOccurs="0"/>
+          <xs:element ref="pc:EntityId3" minOccurs="0"/>
+          <xs:element ref="pc:EntityId4" minOccurs="0"/>
+          <xs:element ref="pc:EntityId5" minOccurs="0"/>
+        </xs:sequence>
+      </xs:complexType>
+    </xs:element>
+    <xs:element name="EntityDisplayName" type="xs:string"/>
+    <xs:element name="EntityInstanceReference" type="xs:string"/>
+    <xs:element name="EntityId1" type="xs:string"/>
+    <xs:element name="EntityId2" type="xs:string"/>
+    <xs:element name="EntityId3" type="xs:string"/>
+    <xs:element name="EntityId4" type="xs:string"/>
+    <xs:element name="EntityId5" type="xs:string"/>
+    <xs:element name="Terms">
+      <xs:complexType>
+        <xs:sequence>
+          <xs:element ref="pc:TermInfo" minOccurs="0" maxOccurs="unbounded"/>
+        </xs:sequence>
+      </xs:complexType>
+    </xs:element>
+    <xs:element name="TermInfo">
+      <xs:complexType>
+        <xs:sequence>
+          <xs:element ref="pc:TermName" minOccurs="0"/>
+          <xs:element ref="pc:TermId" minOccurs="0"/>
+        </xs:sequence>
+      </xs:complexType>
+    </xs:element>
+    <xs:element name="TermName" type="xs:string"/>
+    <xs:element name="TermId" type="xs:string"/>
+  </xs:schema>
+</ct:contentTypeSchema>
+</file>
+
+<file path=customXml/item2.xml><?xml version="1.0" encoding="utf-8"?>
+<?mso-contentType ?>
+<FormTemplates xmlns="http://schemas.microsoft.com/sharepoint/v3/contenttype/forms">
+  <Display>DocumentLibraryForm</Display>
+  <Edit>DocumentLibraryForm</Edit>
+  <New>DocumentLibraryForm</New>
+</FormTemplates>
+</file>
+
+<file path=customXml/item3.xml><?xml version="1.0" encoding="utf-8"?>
+<p:properties xmlns:p="http://schemas.microsoft.com/office/2006/metadata/properties" xmlns:xsi="http://www.w3.org/2001/XMLSchema-instance" xmlns:pc="http://schemas.microsoft.com/office/infopath/2007/PartnerControls">
+  <documentManagement>
+    <TemplateDescription xmlns="ee4fc995-f6d0-4bc8-8771-94b803449598" xsi:nil="true"/>
+  </documentManagement>
+</p:properties>
+</file>
+
+<file path=customXml/itemProps1.xml><?xml version="1.0" encoding="utf-8"?>
+<ds:datastoreItem xmlns:ds="http://schemas.openxmlformats.org/officeDocument/2006/customXml" ds:itemID="{195F3257-6B10-4E08-B224-E4DCB307649F}"/>
+</file>
+
+<file path=customXml/itemProps2.xml><?xml version="1.0" encoding="utf-8"?>
+<ds:datastoreItem xmlns:ds="http://schemas.openxmlformats.org/officeDocument/2006/customXml" ds:itemID="{FB05E5CC-CC08-4966-95D3-6115C005AA7C}">
+  <ds:schemaRefs>
+    <ds:schemaRef ds:uri="http://schemas.microsoft.com/sharepoint/v3/contenttype/forms"/>
+  </ds:schemaRefs>
+</ds:datastoreItem>
+</file>
+
+<file path=customXml/itemProps3.xml><?xml version="1.0" encoding="utf-8"?>
+<ds:datastoreItem xmlns:ds="http://schemas.openxmlformats.org/officeDocument/2006/customXml" ds:itemID="{EC513C62-2817-40DE-A7AD-73AC16E60B37}">
+  <ds:schemaRefs>
+    <ds:schemaRef ds:uri="http://schemas.microsoft.com/office/2006/metadata/properties"/>
+    <ds:schemaRef ds:uri="http://schemas.microsoft.com/office/infopath/2007/PartnerControls"/>
+    <ds:schemaRef ds:uri="9a3394e1-d893-46c7-ba1f-3f2f5571878c"/>
+    <ds:schemaRef ds:uri="dc094c55-e333-406d-a8a5-a982595fcb23"/>
+  </ds:schemaRefs>
+</ds:datastoreItem>
+</file>
+
+<file path=docMetadata/LabelInfo.xml><?xml version="1.0" encoding="utf-8"?>
+<clbl:labelList xmlns:clbl="http://schemas.microsoft.com/office/2020/mipLabelMetadata">
+  <clbl:label id="{cf7ff65a-ced6-400c-9856-fcac58ff39e8}" enabled="0" method="" siteId="{cf7ff65a-ced6-400c-9856-fcac58ff39e8}" removed="1"/>
+</clbl:labelList>
 </file>
</xml_diff>

<commit_message>
fix: drop orphaned notes pages from the bundled PPT templates
The example slides were removed in 2.8.0 but their notesSlide parts,
content-type overrides and app.xml slide counts and titles stayed, and
save_ppt() copied them into every deck. Closes #173. (Rebuilt on main
after #180; the stale-title test from review is folded in.)

Co-Authored-By: Claude Opus 5.5 <noreply@anthropic.com>
</commit_message>
<xml_diff>
--- a/inst/extdata/hv_ppt_template.pptx
+++ b/inst/extdata/hv_ppt_template.pptx
@@ -882,488 +882,6 @@
     </a:lvl9pPr>
   </p:notesStyle>
 </p:notesMaster>
-</file>
-
-<file path=ppt/notesSlides/notesSlide1.xml><?xml version="1.0" encoding="utf-8"?>
-<p:notes xmlns:a="http://schemas.openxmlformats.org/drawingml/2006/main" xmlns:r="http://schemas.openxmlformats.org/officeDocument/2006/relationships" xmlns:p="http://schemas.openxmlformats.org/presentationml/2006/main">
-  <p:cSld>
-    <p:spTree>
-      <p:nvGrpSpPr>
-        <p:cNvPr id="1" name=""/>
-        <p:cNvGrpSpPr/>
-        <p:nvPr/>
-      </p:nvGrpSpPr>
-      <p:grpSpPr>
-        <a:xfrm>
-          <a:off x="0" y="0"/>
-          <a:ext cx="0" cy="0"/>
-          <a:chOff x="0" y="0"/>
-          <a:chExt cx="0" cy="0"/>
-        </a:xfrm>
-      </p:grpSpPr>
-      <p:sp>
-        <p:nvSpPr>
-          <p:cNvPr id="2" name="Slide Image Placeholder 1"/>
-          <p:cNvSpPr>
-            <a:spLocks noGrp="1" noRot="1" noChangeAspect="1"/>
-          </p:cNvSpPr>
-          <p:nvPr>
-            <p:ph type="sldImg"/>
-          </p:nvPr>
-        </p:nvSpPr>
-        <p:spPr/>
-      </p:sp>
-      <p:sp>
-        <p:nvSpPr>
-          <p:cNvPr id="3" name="Notes Placeholder 2"/>
-          <p:cNvSpPr>
-            <a:spLocks noGrp="1"/>
-          </p:cNvSpPr>
-          <p:nvPr>
-            <p:ph type="body" idx="1"/>
-          </p:nvPr>
-        </p:nvSpPr>
-        <p:spPr/>
-        <p:txBody>
-          <a:bodyPr/>
-          <a:lstStyle/>
-          <a:p>
-            <a:r>
-              <a:rPr lang="en-US" b="1" dirty="0"/>
-              <a:t>Try not to use Tables</a:t>
-            </a:r>
-          </a:p>
-        </p:txBody>
-      </p:sp>
-      <p:sp>
-        <p:nvSpPr>
-          <p:cNvPr id="4" name="Slide Number Placeholder 3"/>
-          <p:cNvSpPr>
-            <a:spLocks noGrp="1"/>
-          </p:cNvSpPr>
-          <p:nvPr>
-            <p:ph type="sldNum" sz="quarter" idx="5"/>
-          </p:nvPr>
-        </p:nvSpPr>
-        <p:spPr/>
-        <p:txBody>
-          <a:bodyPr/>
-          <a:lstStyle/>
-          <a:p>
-            <a:pPr>
-              <a:defRPr/>
-            </a:pPr>
-            <a:fld id="{77261A55-EFA6-4C86-86C1-9750DF19D9F0}" type="slidenum">
-              <a:rPr lang="en-US" altLang="en-US" smtClean="0"/>
-              <a:pPr>
-                <a:defRPr/>
-              </a:pPr>
-              <a:t>10</a:t>
-            </a:fld>
-            <a:endParaRPr lang="en-US" altLang="en-US"/>
-          </a:p>
-        </p:txBody>
-      </p:sp>
-    </p:spTree>
-    <p:extLst>
-      <p:ext uri="{BB962C8B-B14F-4D97-AF65-F5344CB8AC3E}">
-        <p14:creationId xmlns:p14="http://schemas.microsoft.com/office/powerpoint/2010/main" val="2423958642"/>
-      </p:ext>
-    </p:extLst>
-  </p:cSld>
-  <p:clrMapOvr>
-    <a:masterClrMapping/>
-  </p:clrMapOvr>
-</p:notes>
-</file>
-
-<file path=ppt/notesSlides/notesSlide2.xml><?xml version="1.0" encoding="utf-8"?>
-<p:notes xmlns:a="http://schemas.openxmlformats.org/drawingml/2006/main" xmlns:r="http://schemas.openxmlformats.org/officeDocument/2006/relationships" xmlns:p="http://schemas.openxmlformats.org/presentationml/2006/main">
-  <p:cSld>
-    <p:spTree>
-      <p:nvGrpSpPr>
-        <p:cNvPr id="1" name=""/>
-        <p:cNvGrpSpPr/>
-        <p:nvPr/>
-      </p:nvGrpSpPr>
-      <p:grpSpPr>
-        <a:xfrm>
-          <a:off x="0" y="0"/>
-          <a:ext cx="0" cy="0"/>
-          <a:chOff x="0" y="0"/>
-          <a:chExt cx="0" cy="0"/>
-        </a:xfrm>
-      </p:grpSpPr>
-      <p:sp>
-        <p:nvSpPr>
-          <p:cNvPr id="7" name="Rectangle 7"/>
-          <p:cNvSpPr>
-            <a:spLocks noGrp="1" noChangeArrowheads="1"/>
-          </p:cNvSpPr>
-          <p:nvPr>
-            <p:ph type="sldNum" sz="quarter" idx="5"/>
-          </p:nvPr>
-        </p:nvSpPr>
-        <p:spPr>
-          <a:ln/>
-        </p:spPr>
-        <p:txBody>
-          <a:bodyPr/>
-          <a:lstStyle/>
-          <a:p>
-            <a:fld id="{623D48AD-1957-4759-B4E1-13C8E0A9AB1A}" type="slidenum">
-              <a:rPr lang="en-US" altLang="en-US"/>
-              <a:pPr/>
-              <a:t>11</a:t>
-            </a:fld>
-            <a:endParaRPr lang="en-US" altLang="en-US"/>
-          </a:p>
-        </p:txBody>
-      </p:sp>
-      <p:sp>
-        <p:nvSpPr>
-          <p:cNvPr id="23554" name="Rectangle 2"/>
-          <p:cNvSpPr>
-            <a:spLocks noGrp="1" noRot="1" noChangeAspect="1" noChangeArrowheads="1" noTextEdit="1"/>
-          </p:cNvSpPr>
-          <p:nvPr>
-            <p:ph type="sldImg"/>
-          </p:nvPr>
-        </p:nvSpPr>
-        <p:spPr>
-          <a:ln/>
-        </p:spPr>
-      </p:sp>
-      <p:sp>
-        <p:nvSpPr>
-          <p:cNvPr id="23555" name="Rectangle 3"/>
-          <p:cNvSpPr>
-            <a:spLocks noGrp="1" noChangeArrowheads="1"/>
-          </p:cNvSpPr>
-          <p:nvPr>
-            <p:ph type="body" idx="1"/>
-          </p:nvPr>
-        </p:nvSpPr>
-        <p:spPr/>
-        <p:txBody>
-          <a:bodyPr/>
-          <a:lstStyle/>
-          <a:p>
-            <a:r>
-              <a:rPr lang="en-US" altLang="en-US" dirty="0"/>
-              <a:t>Pie Chart:</a:t>
-            </a:r>
-          </a:p>
-          <a:p>
-            <a:r>
-              <a:rPr lang="en-US" altLang="en-US" dirty="0"/>
-              <a:t>Double click pie chart to edit data.</a:t>
-            </a:r>
-          </a:p>
-          <a:p>
-            <a:r>
-              <a:rPr lang="en-US" altLang="en-US" dirty="0"/>
-              <a:t>Labels and percentages are added with separate text blocks. Colors are not standardized yet.</a:t>
-            </a:r>
-          </a:p>
-        </p:txBody>
-      </p:sp>
-    </p:spTree>
-    <p:extLst>
-      <p:ext uri="{BB962C8B-B14F-4D97-AF65-F5344CB8AC3E}">
-        <p14:creationId xmlns:p14="http://schemas.microsoft.com/office/powerpoint/2010/main" val="4136693095"/>
-      </p:ext>
-    </p:extLst>
-  </p:cSld>
-  <p:clrMapOvr>
-    <a:masterClrMapping/>
-  </p:clrMapOvr>
-</p:notes>
-</file>
-
-<file path=ppt/notesSlides/notesSlide3.xml><?xml version="1.0" encoding="utf-8"?>
-<p:notes xmlns:a="http://schemas.openxmlformats.org/drawingml/2006/main" xmlns:r="http://schemas.openxmlformats.org/officeDocument/2006/relationships" xmlns:p="http://schemas.openxmlformats.org/presentationml/2006/main">
-  <p:cSld>
-    <p:spTree>
-      <p:nvGrpSpPr>
-        <p:cNvPr id="1" name=""/>
-        <p:cNvGrpSpPr/>
-        <p:nvPr/>
-      </p:nvGrpSpPr>
-      <p:grpSpPr>
-        <a:xfrm>
-          <a:off x="0" y="0"/>
-          <a:ext cx="0" cy="0"/>
-          <a:chOff x="0" y="0"/>
-          <a:chExt cx="0" cy="0"/>
-        </a:xfrm>
-      </p:grpSpPr>
-      <p:sp>
-        <p:nvSpPr>
-          <p:cNvPr id="7" name="Rectangle 7"/>
-          <p:cNvSpPr>
-            <a:spLocks noGrp="1" noChangeArrowheads="1"/>
-          </p:cNvSpPr>
-          <p:nvPr>
-            <p:ph type="sldNum" sz="quarter" idx="5"/>
-          </p:nvPr>
-        </p:nvSpPr>
-        <p:spPr>
-          <a:ln/>
-        </p:spPr>
-        <p:txBody>
-          <a:bodyPr/>
-          <a:lstStyle/>
-          <a:p>
-            <a:fld id="{D557DB31-A8E3-46B3-BAFB-0CF4D9AD5315}" type="slidenum">
-              <a:rPr lang="en-US" altLang="en-US"/>
-              <a:pPr/>
-              <a:t>12</a:t>
-            </a:fld>
-            <a:endParaRPr lang="en-US" altLang="en-US"/>
-          </a:p>
-        </p:txBody>
-      </p:sp>
-      <p:sp>
-        <p:nvSpPr>
-          <p:cNvPr id="28674" name="Rectangle 2"/>
-          <p:cNvSpPr>
-            <a:spLocks noGrp="1" noChangeArrowheads="1"/>
-          </p:cNvSpPr>
-          <p:nvPr>
-            <p:ph type="body" idx="1"/>
-          </p:nvPr>
-        </p:nvSpPr>
-        <p:spPr bwMode="auto">
-          <a:xfrm>
-            <a:off x="912813" y="4343400"/>
-            <a:ext cx="5030787" cy="4114800"/>
-          </a:xfrm>
-          <a:prstGeom prst="rect">
-            <a:avLst/>
-          </a:prstGeom>
-          <a:noFill/>
-          <a:ln/>
-          <a:extLst>
-            <a:ext uri="{909E8E84-426E-40DD-AFC4-6F175D3DCCD1}">
-              <a14:hiddenFill xmlns:a14="http://schemas.microsoft.com/office/drawing/2010/main">
-                <a:solidFill>
-                  <a:srgbClr val="FFFFFF"/>
-                </a:solidFill>
-              </a14:hiddenFill>
-            </a:ext>
-            <a:ext uri="{91240B29-F687-4F45-9708-019B960494DF}">
-              <a14:hiddenLine xmlns:a14="http://schemas.microsoft.com/office/drawing/2010/main" w="12700">
-                <a:solidFill>
-                  <a:srgbClr val="000000"/>
-                </a:solidFill>
-                <a:miter lim="800000"/>
-                <a:headEnd/>
-                <a:tailEnd/>
-              </a14:hiddenLine>
-            </a:ext>
-            <a:ext uri="{AF507438-7753-43E0-B8FC-AC1667EBCBE1}">
-              <a14:hiddenEffects xmlns:a14="http://schemas.microsoft.com/office/drawing/2010/main">
-                <a:effectLst>
-                  <a:outerShdw dist="35921" dir="2700000" algn="ctr" rotWithShape="0">
-                    <a:srgbClr val="808080"/>
-                  </a:outerShdw>
-                </a:effectLst>
-              </a14:hiddenEffects>
-            </a:ext>
-          </a:extLst>
-        </p:spPr>
-        <p:txBody>
-          <a:bodyPr lIns="90488" tIns="44450" rIns="90488" bIns="44450"/>
-          <a:lstStyle/>
-          <a:p>
-            <a:r>
-              <a:rPr lang="en-US" altLang="en-US" sz="2000" dirty="0"/>
-              <a:t>Double click the chart to modify histogram data.  </a:t>
-            </a:r>
-            <a:r>
-              <a:rPr lang="en-US" altLang="en-US" sz="2000" b="1" dirty="0"/>
-              <a:t>Make your own labels(insert text box be sure the size font is 32).</a:t>
-            </a:r>
-          </a:p>
-          <a:p>
-            <a:r>
-              <a:rPr lang="en-US" altLang="en-US" sz="2000" b="1" dirty="0"/>
-              <a:t>Auto-generated axis labels may change the size of your Histogram and decrease in font size to “fit”.  </a:t>
-            </a:r>
-          </a:p>
-          <a:p>
-            <a:r>
-              <a:rPr lang="en-US" altLang="en-US" sz="2000" b="1" dirty="0"/>
-              <a:t>Need another Histogram?  Copy first one and change the data</a:t>
-            </a:r>
-          </a:p>
-          <a:p>
-            <a:r>
-              <a:rPr lang="en-US" altLang="en-US" sz="2000" dirty="0"/>
-              <a:t>You must create your own legend. Ungroup legend objects to edit text or color.</a:t>
-            </a:r>
-          </a:p>
-          <a:p>
-            <a:r>
-              <a:rPr lang="en-US" altLang="en-US" sz="2000" dirty="0"/>
-              <a:t>Colors and size are not standardized yet.</a:t>
-            </a:r>
-          </a:p>
-          <a:p>
-            <a:endParaRPr lang="en-US" altLang="en-US" sz="2000" dirty="0"/>
-          </a:p>
-          <a:p>
-            <a:endParaRPr lang="en-US" altLang="en-US" sz="2000" dirty="0"/>
-          </a:p>
-        </p:txBody>
-      </p:sp>
-      <p:sp>
-        <p:nvSpPr>
-          <p:cNvPr id="28675" name="Rectangle 3"/>
-          <p:cNvSpPr>
-            <a:spLocks noGrp="1" noRot="1" noChangeAspect="1" noChangeArrowheads="1"/>
-          </p:cNvSpPr>
-          <p:nvPr>
-            <p:ph type="sldImg"/>
-          </p:nvPr>
-        </p:nvSpPr>
-        <p:spPr bwMode="auto">
-          <a:xfrm>
-            <a:off x="393700" y="692150"/>
-            <a:ext cx="6070600" cy="3416300"/>
-          </a:xfrm>
-          <a:prstGeom prst="rect">
-            <a:avLst/>
-          </a:prstGeom>
-          <a:noFill/>
-          <a:ln w="12700" cap="flat">
-            <a:solidFill>
-              <a:schemeClr val="tx1"/>
-            </a:solidFill>
-            <a:miter lim="800000"/>
-            <a:headEnd/>
-            <a:tailEnd/>
-          </a:ln>
-          <a:extLst>
-            <a:ext uri="{909E8E84-426E-40DD-AFC4-6F175D3DCCD1}">
-              <a14:hiddenFill xmlns:a14="http://schemas.microsoft.com/office/drawing/2010/main">
-                <a:solidFill>
-                  <a:srgbClr val="FFFFFF"/>
-                </a:solidFill>
-              </a14:hiddenFill>
-            </a:ext>
-            <a:ext uri="{AF507438-7753-43E0-B8FC-AC1667EBCBE1}">
-              <a14:hiddenEffects xmlns:a14="http://schemas.microsoft.com/office/drawing/2010/main">
-                <a:effectLst>
-                  <a:outerShdw dist="35921" dir="2700000" algn="ctr" rotWithShape="0">
-                    <a:srgbClr val="808080"/>
-                  </a:outerShdw>
-                </a:effectLst>
-              </a14:hiddenEffects>
-            </a:ext>
-          </a:extLst>
-        </p:spPr>
-      </p:sp>
-    </p:spTree>
-    <p:extLst>
-      <p:ext uri="{BB962C8B-B14F-4D97-AF65-F5344CB8AC3E}">
-        <p14:creationId xmlns:p14="http://schemas.microsoft.com/office/powerpoint/2010/main" val="2207863968"/>
-      </p:ext>
-    </p:extLst>
-  </p:cSld>
-  <p:clrMapOvr>
-    <a:masterClrMapping/>
-  </p:clrMapOvr>
-</p:notes>
-</file>
-
-<file path=ppt/notesSlides/notesSlide4.xml><?xml version="1.0" encoding="utf-8"?>
-<p:notes xmlns:a="http://schemas.openxmlformats.org/drawingml/2006/main" xmlns:r="http://schemas.openxmlformats.org/officeDocument/2006/relationships" xmlns:p="http://schemas.openxmlformats.org/presentationml/2006/main">
-  <p:cSld>
-    <p:spTree>
-      <p:nvGrpSpPr>
-        <p:cNvPr id="1" name=""/>
-        <p:cNvGrpSpPr/>
-        <p:nvPr/>
-      </p:nvGrpSpPr>
-      <p:grpSpPr>
-        <a:xfrm>
-          <a:off x="0" y="0"/>
-          <a:ext cx="0" cy="0"/>
-          <a:chOff x="0" y="0"/>
-          <a:chExt cx="0" cy="0"/>
-        </a:xfrm>
-      </p:grpSpPr>
-      <p:sp>
-        <p:nvSpPr>
-          <p:cNvPr id="2" name="Slide Image Placeholder 1"/>
-          <p:cNvSpPr>
-            <a:spLocks noGrp="1" noRot="1" noChangeAspect="1"/>
-          </p:cNvSpPr>
-          <p:nvPr>
-            <p:ph type="sldImg"/>
-          </p:nvPr>
-        </p:nvSpPr>
-        <p:spPr/>
-      </p:sp>
-      <p:sp>
-        <p:nvSpPr>
-          <p:cNvPr id="3" name="Notes Placeholder 2"/>
-          <p:cNvSpPr>
-            <a:spLocks noGrp="1"/>
-          </p:cNvSpPr>
-          <p:nvPr>
-            <p:ph type="body" idx="1"/>
-          </p:nvPr>
-        </p:nvSpPr>
-        <p:spPr/>
-        <p:txBody>
-          <a:bodyPr/>
-          <a:lstStyle/>
-          <a:p>
-            <a:r>
-              <a:rPr lang="en-US" b="1" dirty="0"/>
-              <a:t>Extra slides that may or may not be used, don’t just delete!</a:t>
-            </a:r>
-          </a:p>
-        </p:txBody>
-      </p:sp>
-      <p:sp>
-        <p:nvSpPr>
-          <p:cNvPr id="4" name="Slide Number Placeholder 3"/>
-          <p:cNvSpPr>
-            <a:spLocks noGrp="1"/>
-          </p:cNvSpPr>
-          <p:nvPr>
-            <p:ph type="sldNum" sz="quarter" idx="5"/>
-          </p:nvPr>
-        </p:nvSpPr>
-        <p:spPr/>
-        <p:txBody>
-          <a:bodyPr/>
-          <a:lstStyle/>
-          <a:p>
-            <a:fld id="{98DB9D90-18B0-4CF8-86DE-169EA001EB17}" type="slidenum">
-              <a:rPr lang="en-US" altLang="en-US" smtClean="0"/>
-              <a:pPr/>
-              <a:t>15</a:t>
-            </a:fld>
-            <a:endParaRPr lang="en-US" altLang="en-US"/>
-          </a:p>
-        </p:txBody>
-      </p:sp>
-    </p:spTree>
-    <p:extLst>
-      <p:ext uri="{BB962C8B-B14F-4D97-AF65-F5344CB8AC3E}">
-        <p14:creationId xmlns:p14="http://schemas.microsoft.com/office/powerpoint/2010/main" val="2193846798"/>
-      </p:ext>
-    </p:extLst>
-  </p:cSld>
-  <p:clrMapOvr>
-    <a:masterClrMapping/>
-  </p:clrMapOvr>
-</p:notes>
 </file>
 
 <file path=ppt/slideLayouts/slideLayout1.xml><?xml version="1.0" encoding="utf-8"?>

</xml_diff>